<commit_message>
v1.1.0: PDF output, milestones on the Gantt, robust HTML preview, first-person README
</commit_message>
<xml_diff>
--- a/assets/sample-outputs/sample-project-plan.pptx
+++ b/assets/sample-outputs/sample-project-plan.pptx
@@ -5258,7 +5258,808 @@
         </p:nvSpPr>
         <p:spPr>
           <a:xfrm>
-            <a:off x="548640" y="2359152"/>
+            <a:off x="548640" y="2112264"/>
+            <a:ext cx="1463040" cy="201168"/>
+          </a:xfrm>
+          <a:prstGeom prst="rect">
+            <a:avLst/>
+          </a:prstGeom>
+          <a:noFill/>
+        </p:spPr>
+        <p:txBody>
+          <a:bodyPr wrap="square" lIns="0" rIns="0" tIns="0" bIns="0" anchor="t">
+            <a:spAutoFit/>
+          </a:bodyPr>
+          <a:lstStyle/>
+          <a:p>
+            <a:pPr algn="l">
+              <a:lnSpc>
+                <a:spcPct val="115000"/>
+              </a:lnSpc>
+            </a:pPr>
+            <a:r>
+              <a:rPr sz="800" b="1" i="0">
+                <a:solidFill>
+                  <a:srgbClr val="8A8A8A"/>
+                </a:solidFill>
+                <a:latin typeface="Calibri"/>
+              </a:rPr>
+              <a:t>MILESTONES</a:t>
+            </a:r>
+          </a:p>
+        </p:txBody>
+      </p:sp>
+      <p:sp>
+        <p:nvSpPr>
+          <p:cNvPr id="19" name="Diamond 18"/>
+          <p:cNvSpPr/>
+          <p:nvPr/>
+        </p:nvSpPr>
+        <p:spPr>
+          <a:xfrm>
+            <a:off x="3238544" y="2249424"/>
+            <a:ext cx="128016" cy="128016"/>
+          </a:xfrm>
+          <a:prstGeom prst="diamond">
+            <a:avLst/>
+          </a:prstGeom>
+          <a:solidFill>
+            <a:srgbClr val="3F7A52"/>
+          </a:solidFill>
+          <a:ln w="9525">
+            <a:solidFill>
+              <a:srgbClr val="FFFFFF"/>
+            </a:solidFill>
+          </a:ln>
+          <a:effectLst/>
+        </p:spPr>
+        <p:style>
+          <a:lnRef idx="1">
+            <a:schemeClr val="accent1"/>
+          </a:lnRef>
+          <a:fillRef idx="3">
+            <a:schemeClr val="accent1"/>
+          </a:fillRef>
+          <a:effectRef idx="2">
+            <a:schemeClr val="accent1"/>
+          </a:effectRef>
+          <a:fontRef idx="minor">
+            <a:schemeClr val="lt1"/>
+          </a:fontRef>
+        </p:style>
+        <p:txBody>
+          <a:bodyPr rtlCol="0" anchor="ctr"/>
+          <a:lstStyle/>
+          <a:p>
+            <a:pPr algn="ctr"/>
+          </a:p>
+        </p:txBody>
+      </p:sp>
+      <p:sp>
+        <p:nvSpPr>
+          <p:cNvPr id="20" name="TextBox 19"/>
+          <p:cNvSpPr txBox="1"/>
+          <p:nvPr/>
+        </p:nvSpPr>
+        <p:spPr>
+          <a:xfrm>
+            <a:off x="2891072" y="2395728"/>
+            <a:ext cx="822959" cy="164592"/>
+          </a:xfrm>
+          <a:prstGeom prst="rect">
+            <a:avLst/>
+          </a:prstGeom>
+          <a:noFill/>
+        </p:spPr>
+        <p:txBody>
+          <a:bodyPr wrap="square" lIns="0" rIns="0" tIns="0" bIns="0" anchor="t">
+            <a:spAutoFit/>
+          </a:bodyPr>
+          <a:lstStyle/>
+          <a:p>
+            <a:pPr algn="ctr">
+              <a:lnSpc>
+                <a:spcPct val="115000"/>
+              </a:lnSpc>
+            </a:pPr>
+            <a:r>
+              <a:rPr sz="750" b="0" i="0">
+                <a:solidFill>
+                  <a:srgbClr val="4A4A4A"/>
+                </a:solidFill>
+                <a:latin typeface="Calibri"/>
+              </a:rPr>
+              <a:t>27 Mar</a:t>
+            </a:r>
+          </a:p>
+        </p:txBody>
+      </p:sp>
+      <p:sp>
+        <p:nvSpPr>
+          <p:cNvPr id="21" name="Diamond 20"/>
+          <p:cNvSpPr/>
+          <p:nvPr/>
+        </p:nvSpPr>
+        <p:spPr>
+          <a:xfrm>
+            <a:off x="4169257" y="2249424"/>
+            <a:ext cx="128016" cy="128016"/>
+          </a:xfrm>
+          <a:prstGeom prst="diamond">
+            <a:avLst/>
+          </a:prstGeom>
+          <a:solidFill>
+            <a:srgbClr val="3F7A52"/>
+          </a:solidFill>
+          <a:ln w="9525">
+            <a:solidFill>
+              <a:srgbClr val="FFFFFF"/>
+            </a:solidFill>
+          </a:ln>
+          <a:effectLst/>
+        </p:spPr>
+        <p:style>
+          <a:lnRef idx="1">
+            <a:schemeClr val="accent1"/>
+          </a:lnRef>
+          <a:fillRef idx="3">
+            <a:schemeClr val="accent1"/>
+          </a:fillRef>
+          <a:effectRef idx="2">
+            <a:schemeClr val="accent1"/>
+          </a:effectRef>
+          <a:fontRef idx="minor">
+            <a:schemeClr val="lt1"/>
+          </a:fontRef>
+        </p:style>
+        <p:txBody>
+          <a:bodyPr rtlCol="0" anchor="ctr"/>
+          <a:lstStyle/>
+          <a:p>
+            <a:pPr algn="ctr"/>
+          </a:p>
+        </p:txBody>
+      </p:sp>
+      <p:sp>
+        <p:nvSpPr>
+          <p:cNvPr id="22" name="TextBox 21"/>
+          <p:cNvSpPr txBox="1"/>
+          <p:nvPr/>
+        </p:nvSpPr>
+        <p:spPr>
+          <a:xfrm>
+            <a:off x="3821785" y="2395728"/>
+            <a:ext cx="822959" cy="164592"/>
+          </a:xfrm>
+          <a:prstGeom prst="rect">
+            <a:avLst/>
+          </a:prstGeom>
+          <a:noFill/>
+        </p:spPr>
+        <p:txBody>
+          <a:bodyPr wrap="square" lIns="0" rIns="0" tIns="0" bIns="0" anchor="t">
+            <a:spAutoFit/>
+          </a:bodyPr>
+          <a:lstStyle/>
+          <a:p>
+            <a:pPr algn="ctr">
+              <a:lnSpc>
+                <a:spcPct val="115000"/>
+              </a:lnSpc>
+            </a:pPr>
+            <a:r>
+              <a:rPr sz="750" b="0" i="0">
+                <a:solidFill>
+                  <a:srgbClr val="4A4A4A"/>
+                </a:solidFill>
+                <a:latin typeface="Calibri"/>
+              </a:rPr>
+              <a:t>17 Apr</a:t>
+            </a:r>
+          </a:p>
+        </p:txBody>
+      </p:sp>
+      <p:sp>
+        <p:nvSpPr>
+          <p:cNvPr id="23" name="Diamond 22"/>
+          <p:cNvSpPr/>
+          <p:nvPr/>
+        </p:nvSpPr>
+        <p:spPr>
+          <a:xfrm>
+            <a:off x="4745413" y="2249424"/>
+            <a:ext cx="128016" cy="128016"/>
+          </a:xfrm>
+          <a:prstGeom prst="diamond">
+            <a:avLst/>
+          </a:prstGeom>
+          <a:solidFill>
+            <a:srgbClr val="AE7A2A"/>
+          </a:solidFill>
+          <a:ln w="9525">
+            <a:solidFill>
+              <a:srgbClr val="FFFFFF"/>
+            </a:solidFill>
+          </a:ln>
+          <a:effectLst/>
+        </p:spPr>
+        <p:style>
+          <a:lnRef idx="1">
+            <a:schemeClr val="accent1"/>
+          </a:lnRef>
+          <a:fillRef idx="3">
+            <a:schemeClr val="accent1"/>
+          </a:fillRef>
+          <a:effectRef idx="2">
+            <a:schemeClr val="accent1"/>
+          </a:effectRef>
+          <a:fontRef idx="minor">
+            <a:schemeClr val="lt1"/>
+          </a:fontRef>
+        </p:style>
+        <p:txBody>
+          <a:bodyPr rtlCol="0" anchor="ctr"/>
+          <a:lstStyle/>
+          <a:p>
+            <a:pPr algn="ctr"/>
+          </a:p>
+        </p:txBody>
+      </p:sp>
+      <p:sp>
+        <p:nvSpPr>
+          <p:cNvPr id="24" name="TextBox 23"/>
+          <p:cNvSpPr txBox="1"/>
+          <p:nvPr/>
+        </p:nvSpPr>
+        <p:spPr>
+          <a:xfrm>
+            <a:off x="4397941" y="2066544"/>
+            <a:ext cx="822959" cy="164592"/>
+          </a:xfrm>
+          <a:prstGeom prst="rect">
+            <a:avLst/>
+          </a:prstGeom>
+          <a:noFill/>
+        </p:spPr>
+        <p:txBody>
+          <a:bodyPr wrap="square" lIns="0" rIns="0" tIns="0" bIns="0" anchor="t">
+            <a:spAutoFit/>
+          </a:bodyPr>
+          <a:lstStyle/>
+          <a:p>
+            <a:pPr algn="ctr">
+              <a:lnSpc>
+                <a:spcPct val="115000"/>
+              </a:lnSpc>
+            </a:pPr>
+            <a:r>
+              <a:rPr sz="750" b="0" i="0">
+                <a:solidFill>
+                  <a:srgbClr val="4A4A4A"/>
+                </a:solidFill>
+                <a:latin typeface="Calibri"/>
+              </a:rPr>
+              <a:t>30 Apr</a:t>
+            </a:r>
+          </a:p>
+        </p:txBody>
+      </p:sp>
+      <p:sp>
+        <p:nvSpPr>
+          <p:cNvPr id="25" name="Diamond 24"/>
+          <p:cNvSpPr/>
+          <p:nvPr/>
+        </p:nvSpPr>
+        <p:spPr>
+          <a:xfrm>
+            <a:off x="4789733" y="2249424"/>
+            <a:ext cx="128016" cy="128016"/>
+          </a:xfrm>
+          <a:prstGeom prst="diamond">
+            <a:avLst/>
+          </a:prstGeom>
+          <a:solidFill>
+            <a:srgbClr val="3F7A52"/>
+          </a:solidFill>
+          <a:ln w="9525">
+            <a:solidFill>
+              <a:srgbClr val="FFFFFF"/>
+            </a:solidFill>
+          </a:ln>
+          <a:effectLst/>
+        </p:spPr>
+        <p:style>
+          <a:lnRef idx="1">
+            <a:schemeClr val="accent1"/>
+          </a:lnRef>
+          <a:fillRef idx="3">
+            <a:schemeClr val="accent1"/>
+          </a:fillRef>
+          <a:effectRef idx="2">
+            <a:schemeClr val="accent1"/>
+          </a:effectRef>
+          <a:fontRef idx="minor">
+            <a:schemeClr val="lt1"/>
+          </a:fontRef>
+        </p:style>
+        <p:txBody>
+          <a:bodyPr rtlCol="0" anchor="ctr"/>
+          <a:lstStyle/>
+          <a:p>
+            <a:pPr algn="ctr"/>
+          </a:p>
+        </p:txBody>
+      </p:sp>
+      <p:sp>
+        <p:nvSpPr>
+          <p:cNvPr id="26" name="Diamond 25"/>
+          <p:cNvSpPr/>
+          <p:nvPr/>
+        </p:nvSpPr>
+        <p:spPr>
+          <a:xfrm>
+            <a:off x="5099970" y="2249424"/>
+            <a:ext cx="128016" cy="128016"/>
+          </a:xfrm>
+          <a:prstGeom prst="diamond">
+            <a:avLst/>
+          </a:prstGeom>
+          <a:solidFill>
+            <a:srgbClr val="3F7A52"/>
+          </a:solidFill>
+          <a:ln w="9525">
+            <a:solidFill>
+              <a:srgbClr val="FFFFFF"/>
+            </a:solidFill>
+          </a:ln>
+          <a:effectLst/>
+        </p:spPr>
+        <p:style>
+          <a:lnRef idx="1">
+            <a:schemeClr val="accent1"/>
+          </a:lnRef>
+          <a:fillRef idx="3">
+            <a:schemeClr val="accent1"/>
+          </a:fillRef>
+          <a:effectRef idx="2">
+            <a:schemeClr val="accent1"/>
+          </a:effectRef>
+          <a:fontRef idx="minor">
+            <a:schemeClr val="lt1"/>
+          </a:fontRef>
+        </p:style>
+        <p:txBody>
+          <a:bodyPr rtlCol="0" anchor="ctr"/>
+          <a:lstStyle/>
+          <a:p>
+            <a:pPr algn="ctr"/>
+          </a:p>
+        </p:txBody>
+      </p:sp>
+      <p:sp>
+        <p:nvSpPr>
+          <p:cNvPr id="27" name="TextBox 26"/>
+          <p:cNvSpPr txBox="1"/>
+          <p:nvPr/>
+        </p:nvSpPr>
+        <p:spPr>
+          <a:xfrm>
+            <a:off x="4821078" y="2395728"/>
+            <a:ext cx="685800" cy="164592"/>
+          </a:xfrm>
+          <a:prstGeom prst="rect">
+            <a:avLst/>
+          </a:prstGeom>
+          <a:noFill/>
+        </p:spPr>
+        <p:txBody>
+          <a:bodyPr wrap="square" lIns="0" rIns="0" tIns="0" bIns="0" anchor="t">
+            <a:spAutoFit/>
+          </a:bodyPr>
+          <a:lstStyle/>
+          <a:p>
+            <a:pPr algn="ctr">
+              <a:lnSpc>
+                <a:spcPct val="115000"/>
+              </a:lnSpc>
+            </a:pPr>
+            <a:r>
+              <a:rPr sz="750" b="0" i="0">
+                <a:solidFill>
+                  <a:srgbClr val="4A4A4A"/>
+                </a:solidFill>
+                <a:latin typeface="Calibri"/>
+              </a:rPr>
+              <a:t>8 May</a:t>
+            </a:r>
+          </a:p>
+        </p:txBody>
+      </p:sp>
+      <p:sp>
+        <p:nvSpPr>
+          <p:cNvPr id="28" name="Diamond 27"/>
+          <p:cNvSpPr/>
+          <p:nvPr/>
+        </p:nvSpPr>
+        <p:spPr>
+          <a:xfrm>
+            <a:off x="6961397" y="2249424"/>
+            <a:ext cx="128016" cy="128016"/>
+          </a:xfrm>
+          <a:prstGeom prst="diamond">
+            <a:avLst/>
+          </a:prstGeom>
+          <a:solidFill>
+            <a:srgbClr val="3F7A52"/>
+          </a:solidFill>
+          <a:ln w="9525">
+            <a:solidFill>
+              <a:srgbClr val="FFFFFF"/>
+            </a:solidFill>
+          </a:ln>
+          <a:effectLst/>
+        </p:spPr>
+        <p:style>
+          <a:lnRef idx="1">
+            <a:schemeClr val="accent1"/>
+          </a:lnRef>
+          <a:fillRef idx="3">
+            <a:schemeClr val="accent1"/>
+          </a:fillRef>
+          <a:effectRef idx="2">
+            <a:schemeClr val="accent1"/>
+          </a:effectRef>
+          <a:fontRef idx="minor">
+            <a:schemeClr val="lt1"/>
+          </a:fontRef>
+        </p:style>
+        <p:txBody>
+          <a:bodyPr rtlCol="0" anchor="ctr"/>
+          <a:lstStyle/>
+          <a:p>
+            <a:pPr algn="ctr"/>
+          </a:p>
+        </p:txBody>
+      </p:sp>
+      <p:sp>
+        <p:nvSpPr>
+          <p:cNvPr id="29" name="TextBox 28"/>
+          <p:cNvSpPr txBox="1"/>
+          <p:nvPr/>
+        </p:nvSpPr>
+        <p:spPr>
+          <a:xfrm>
+            <a:off x="6613925" y="2395728"/>
+            <a:ext cx="822959" cy="164592"/>
+          </a:xfrm>
+          <a:prstGeom prst="rect">
+            <a:avLst/>
+          </a:prstGeom>
+          <a:noFill/>
+        </p:spPr>
+        <p:txBody>
+          <a:bodyPr wrap="square" lIns="0" rIns="0" tIns="0" bIns="0" anchor="t">
+            <a:spAutoFit/>
+          </a:bodyPr>
+          <a:lstStyle/>
+          <a:p>
+            <a:pPr algn="ctr">
+              <a:lnSpc>
+                <a:spcPct val="115000"/>
+              </a:lnSpc>
+            </a:pPr>
+            <a:r>
+              <a:rPr sz="750" b="0" i="0">
+                <a:solidFill>
+                  <a:srgbClr val="4A4A4A"/>
+                </a:solidFill>
+                <a:latin typeface="Calibri"/>
+              </a:rPr>
+              <a:t>19 Jun</a:t>
+            </a:r>
+          </a:p>
+        </p:txBody>
+      </p:sp>
+      <p:sp>
+        <p:nvSpPr>
+          <p:cNvPr id="30" name="Diamond 29"/>
+          <p:cNvSpPr/>
+          <p:nvPr/>
+        </p:nvSpPr>
+        <p:spPr>
+          <a:xfrm>
+            <a:off x="8512586" y="2249424"/>
+            <a:ext cx="128016" cy="128016"/>
+          </a:xfrm>
+          <a:prstGeom prst="diamond">
+            <a:avLst/>
+          </a:prstGeom>
+          <a:solidFill>
+            <a:srgbClr val="3F7A52"/>
+          </a:solidFill>
+          <a:ln w="9525">
+            <a:solidFill>
+              <a:srgbClr val="FFFFFF"/>
+            </a:solidFill>
+          </a:ln>
+          <a:effectLst/>
+        </p:spPr>
+        <p:style>
+          <a:lnRef idx="1">
+            <a:schemeClr val="accent1"/>
+          </a:lnRef>
+          <a:fillRef idx="3">
+            <a:schemeClr val="accent1"/>
+          </a:fillRef>
+          <a:effectRef idx="2">
+            <a:schemeClr val="accent1"/>
+          </a:effectRef>
+          <a:fontRef idx="minor">
+            <a:schemeClr val="lt1"/>
+          </a:fontRef>
+        </p:style>
+        <p:txBody>
+          <a:bodyPr rtlCol="0" anchor="ctr"/>
+          <a:lstStyle/>
+          <a:p>
+            <a:pPr algn="ctr"/>
+          </a:p>
+        </p:txBody>
+      </p:sp>
+      <p:sp>
+        <p:nvSpPr>
+          <p:cNvPr id="31" name="TextBox 30"/>
+          <p:cNvSpPr txBox="1"/>
+          <p:nvPr/>
+        </p:nvSpPr>
+        <p:spPr>
+          <a:xfrm>
+            <a:off x="8165114" y="2395728"/>
+            <a:ext cx="822959" cy="164592"/>
+          </a:xfrm>
+          <a:prstGeom prst="rect">
+            <a:avLst/>
+          </a:prstGeom>
+          <a:noFill/>
+        </p:spPr>
+        <p:txBody>
+          <a:bodyPr wrap="square" lIns="0" rIns="0" tIns="0" bIns="0" anchor="t">
+            <a:spAutoFit/>
+          </a:bodyPr>
+          <a:lstStyle/>
+          <a:p>
+            <a:pPr algn="ctr">
+              <a:lnSpc>
+                <a:spcPct val="115000"/>
+              </a:lnSpc>
+            </a:pPr>
+            <a:r>
+              <a:rPr sz="750" b="0" i="0">
+                <a:solidFill>
+                  <a:srgbClr val="4A4A4A"/>
+                </a:solidFill>
+                <a:latin typeface="Calibri"/>
+              </a:rPr>
+              <a:t>24 Jul</a:t>
+            </a:r>
+          </a:p>
+        </p:txBody>
+      </p:sp>
+      <p:sp>
+        <p:nvSpPr>
+          <p:cNvPr id="32" name="Diamond 31"/>
+          <p:cNvSpPr/>
+          <p:nvPr/>
+        </p:nvSpPr>
+        <p:spPr>
+          <a:xfrm>
+            <a:off x="10861530" y="2249424"/>
+            <a:ext cx="128016" cy="128016"/>
+          </a:xfrm>
+          <a:prstGeom prst="diamond">
+            <a:avLst/>
+          </a:prstGeom>
+          <a:solidFill>
+            <a:srgbClr val="3F7A52"/>
+          </a:solidFill>
+          <a:ln w="9525">
+            <a:solidFill>
+              <a:srgbClr val="FFFFFF"/>
+            </a:solidFill>
+          </a:ln>
+          <a:effectLst/>
+        </p:spPr>
+        <p:style>
+          <a:lnRef idx="1">
+            <a:schemeClr val="accent1"/>
+          </a:lnRef>
+          <a:fillRef idx="3">
+            <a:schemeClr val="accent1"/>
+          </a:fillRef>
+          <a:effectRef idx="2">
+            <a:schemeClr val="accent1"/>
+          </a:effectRef>
+          <a:fontRef idx="minor">
+            <a:schemeClr val="lt1"/>
+          </a:fontRef>
+        </p:style>
+        <p:txBody>
+          <a:bodyPr rtlCol="0" anchor="ctr"/>
+          <a:lstStyle/>
+          <a:p>
+            <a:pPr algn="ctr"/>
+          </a:p>
+        </p:txBody>
+      </p:sp>
+      <p:sp>
+        <p:nvSpPr>
+          <p:cNvPr id="33" name="TextBox 32"/>
+          <p:cNvSpPr txBox="1"/>
+          <p:nvPr/>
+        </p:nvSpPr>
+        <p:spPr>
+          <a:xfrm>
+            <a:off x="10514058" y="2395728"/>
+            <a:ext cx="822959" cy="164592"/>
+          </a:xfrm>
+          <a:prstGeom prst="rect">
+            <a:avLst/>
+          </a:prstGeom>
+          <a:noFill/>
+        </p:spPr>
+        <p:txBody>
+          <a:bodyPr wrap="square" lIns="0" rIns="0" tIns="0" bIns="0" anchor="t">
+            <a:spAutoFit/>
+          </a:bodyPr>
+          <a:lstStyle/>
+          <a:p>
+            <a:pPr algn="ctr">
+              <a:lnSpc>
+                <a:spcPct val="115000"/>
+              </a:lnSpc>
+            </a:pPr>
+            <a:r>
+              <a:rPr sz="750" b="0" i="0">
+                <a:solidFill>
+                  <a:srgbClr val="4A4A4A"/>
+                </a:solidFill>
+                <a:latin typeface="Calibri"/>
+              </a:rPr>
+              <a:t>15 Sep</a:t>
+            </a:r>
+          </a:p>
+        </p:txBody>
+      </p:sp>
+      <p:sp>
+        <p:nvSpPr>
+          <p:cNvPr id="34" name="Diamond 33"/>
+          <p:cNvSpPr/>
+          <p:nvPr/>
+        </p:nvSpPr>
+        <p:spPr>
+          <a:xfrm>
+            <a:off x="11304727" y="2249424"/>
+            <a:ext cx="128016" cy="128016"/>
+          </a:xfrm>
+          <a:prstGeom prst="diamond">
+            <a:avLst/>
+          </a:prstGeom>
+          <a:solidFill>
+            <a:srgbClr val="3F7A52"/>
+          </a:solidFill>
+          <a:ln w="9525">
+            <a:solidFill>
+              <a:srgbClr val="FFFFFF"/>
+            </a:solidFill>
+          </a:ln>
+          <a:effectLst/>
+        </p:spPr>
+        <p:style>
+          <a:lnRef idx="1">
+            <a:schemeClr val="accent1"/>
+          </a:lnRef>
+          <a:fillRef idx="3">
+            <a:schemeClr val="accent1"/>
+          </a:fillRef>
+          <a:effectRef idx="2">
+            <a:schemeClr val="accent1"/>
+          </a:effectRef>
+          <a:fontRef idx="minor">
+            <a:schemeClr val="lt1"/>
+          </a:fontRef>
+        </p:style>
+        <p:txBody>
+          <a:bodyPr rtlCol="0" anchor="ctr"/>
+          <a:lstStyle/>
+          <a:p>
+            <a:pPr algn="ctr"/>
+          </a:p>
+        </p:txBody>
+      </p:sp>
+      <p:sp>
+        <p:nvSpPr>
+          <p:cNvPr id="35" name="TextBox 34"/>
+          <p:cNvSpPr txBox="1"/>
+          <p:nvPr/>
+        </p:nvSpPr>
+        <p:spPr>
+          <a:xfrm>
+            <a:off x="10957255" y="2066544"/>
+            <a:ext cx="822959" cy="164592"/>
+          </a:xfrm>
+          <a:prstGeom prst="rect">
+            <a:avLst/>
+          </a:prstGeom>
+          <a:noFill/>
+        </p:spPr>
+        <p:txBody>
+          <a:bodyPr wrap="square" lIns="0" rIns="0" tIns="0" bIns="0" anchor="t">
+            <a:spAutoFit/>
+          </a:bodyPr>
+          <a:lstStyle/>
+          <a:p>
+            <a:pPr algn="ctr">
+              <a:lnSpc>
+                <a:spcPct val="115000"/>
+              </a:lnSpc>
+            </a:pPr>
+            <a:r>
+              <a:rPr sz="750" b="0" i="0">
+                <a:solidFill>
+                  <a:srgbClr val="4A4A4A"/>
+                </a:solidFill>
+                <a:latin typeface="Calibri"/>
+              </a:rPr>
+              <a:t>25 Sep</a:t>
+            </a:r>
+          </a:p>
+        </p:txBody>
+      </p:sp>
+      <p:cxnSp>
+        <p:nvCxnSpPr>
+          <p:cNvPr id="36" name="Connector 35"/>
+          <p:cNvCxnSpPr/>
+          <p:nvPr/>
+        </p:nvCxnSpPr>
+        <p:spPr>
+          <a:xfrm>
+            <a:off x="2194560" y="2514600"/>
+            <a:ext cx="9174175" cy="0"/>
+          </a:xfrm>
+          <a:prstGeom prst="line">
+            <a:avLst/>
+          </a:prstGeom>
+          <a:ln w="5080">
+            <a:solidFill>
+              <a:srgbClr val="EFEFEF"/>
+            </a:solidFill>
+          </a:ln>
+          <a:effectLst/>
+        </p:spPr>
+        <p:style>
+          <a:lnRef idx="2">
+            <a:schemeClr val="accent1"/>
+          </a:lnRef>
+          <a:fillRef idx="0">
+            <a:schemeClr val="accent1"/>
+          </a:fillRef>
+          <a:effectRef idx="1">
+            <a:schemeClr val="accent1"/>
+          </a:effectRef>
+          <a:fontRef idx="minor">
+            <a:schemeClr val="tx1"/>
+          </a:fontRef>
+        </p:style>
+      </p:cxnSp>
+      <p:sp>
+        <p:nvSpPr>
+          <p:cNvPr id="37" name="TextBox 36"/>
+          <p:cNvSpPr txBox="1"/>
+          <p:nvPr/>
+        </p:nvSpPr>
+        <p:spPr>
+          <a:xfrm>
+            <a:off x="548640" y="2816352"/>
             <a:ext cx="1463040" cy="274320"/>
           </a:xfrm>
           <a:prstGeom prst="rect">
@@ -5291,13 +6092,13 @@
       </p:sp>
       <p:sp>
         <p:nvSpPr>
-          <p:cNvPr id="19" name="TextBox 18"/>
-          <p:cNvSpPr txBox="1"/>
-          <p:nvPr/>
-        </p:nvSpPr>
-        <p:spPr>
-          <a:xfrm>
-            <a:off x="548640" y="2560320"/>
+          <p:cNvPr id="38" name="TextBox 37"/>
+          <p:cNvSpPr txBox="1"/>
+          <p:nvPr/>
+        </p:nvSpPr>
+        <p:spPr>
+          <a:xfrm>
+            <a:off x="548640" y="3017520"/>
             <a:ext cx="1463040" cy="219456"/>
           </a:xfrm>
           <a:prstGeom prst="rect">
@@ -5330,13 +6131,13 @@
       </p:sp>
       <p:sp>
         <p:nvSpPr>
-          <p:cNvPr id="20" name="Rounded Rectangle 19"/>
+          <p:cNvPr id="39" name="Rounded Rectangle 38"/>
           <p:cNvSpPr/>
           <p:nvPr/>
         </p:nvSpPr>
         <p:spPr>
           <a:xfrm>
-            <a:off x="2194560" y="2359152"/>
+            <a:off x="2194560" y="2816352"/>
             <a:ext cx="2659181" cy="347472"/>
           </a:xfrm>
           <a:prstGeom prst="roundRect">
@@ -5376,13 +6177,13 @@
       </p:sp>
       <p:sp>
         <p:nvSpPr>
-          <p:cNvPr id="21" name="Rounded Rectangle 20"/>
+          <p:cNvPr id="40" name="Rounded Rectangle 39"/>
           <p:cNvSpPr/>
           <p:nvPr/>
         </p:nvSpPr>
         <p:spPr>
           <a:xfrm>
-            <a:off x="2194560" y="2359152"/>
+            <a:off x="2194560" y="2816352"/>
             <a:ext cx="1953919" cy="347472"/>
           </a:xfrm>
           <a:prstGeom prst="roundRect">
@@ -5422,13 +6223,13 @@
       </p:sp>
       <p:sp>
         <p:nvSpPr>
-          <p:cNvPr id="22" name="TextBox 21"/>
-          <p:cNvSpPr txBox="1"/>
-          <p:nvPr/>
-        </p:nvSpPr>
-        <p:spPr>
-          <a:xfrm>
-            <a:off x="2304288" y="2386584"/>
+          <p:cNvPr id="41" name="TextBox 40"/>
+          <p:cNvSpPr txBox="1"/>
+          <p:nvPr/>
+        </p:nvSpPr>
+        <p:spPr>
+          <a:xfrm>
+            <a:off x="2304288" y="2843784"/>
             <a:ext cx="2439725" cy="274320"/>
           </a:xfrm>
           <a:prstGeom prst="rect">
@@ -5461,13 +6262,13 @@
       </p:sp>
       <p:sp>
         <p:nvSpPr>
-          <p:cNvPr id="23" name="TextBox 22"/>
-          <p:cNvSpPr txBox="1"/>
-          <p:nvPr/>
-        </p:nvSpPr>
-        <p:spPr>
-          <a:xfrm>
-            <a:off x="548640" y="3008376"/>
+          <p:cNvPr id="42" name="TextBox 41"/>
+          <p:cNvSpPr txBox="1"/>
+          <p:nvPr/>
+        </p:nvSpPr>
+        <p:spPr>
+          <a:xfrm>
+            <a:off x="548640" y="3465576"/>
             <a:ext cx="1463040" cy="274320"/>
           </a:xfrm>
           <a:prstGeom prst="rect">
@@ -5500,13 +6301,13 @@
       </p:sp>
       <p:sp>
         <p:nvSpPr>
-          <p:cNvPr id="24" name="TextBox 23"/>
-          <p:cNvSpPr txBox="1"/>
-          <p:nvPr/>
-        </p:nvSpPr>
-        <p:spPr>
-          <a:xfrm>
-            <a:off x="548640" y="3209544"/>
+          <p:cNvPr id="43" name="TextBox 42"/>
+          <p:cNvSpPr txBox="1"/>
+          <p:nvPr/>
+        </p:nvSpPr>
+        <p:spPr>
+          <a:xfrm>
+            <a:off x="548640" y="3666744"/>
             <a:ext cx="1463040" cy="219456"/>
           </a:xfrm>
           <a:prstGeom prst="rect">
@@ -5539,13 +6340,13 @@
       </p:sp>
       <p:sp>
         <p:nvSpPr>
-          <p:cNvPr id="25" name="Rounded Rectangle 24"/>
+          <p:cNvPr id="44" name="Rounded Rectangle 43"/>
           <p:cNvSpPr/>
           <p:nvPr/>
         </p:nvSpPr>
         <p:spPr>
           <a:xfrm>
-            <a:off x="4986700" y="3008376"/>
+            <a:off x="4986700" y="3465576"/>
             <a:ext cx="2038705" cy="347472"/>
           </a:xfrm>
           <a:prstGeom prst="roundRect">
@@ -5585,13 +6386,13 @@
       </p:sp>
       <p:sp>
         <p:nvSpPr>
-          <p:cNvPr id="26" name="TextBox 25"/>
-          <p:cNvSpPr txBox="1"/>
-          <p:nvPr/>
-        </p:nvSpPr>
-        <p:spPr>
-          <a:xfrm>
-            <a:off x="5096428" y="3035808"/>
+          <p:cNvPr id="45" name="TextBox 44"/>
+          <p:cNvSpPr txBox="1"/>
+          <p:nvPr/>
+        </p:nvSpPr>
+        <p:spPr>
+          <a:xfrm>
+            <a:off x="5096428" y="3493008"/>
             <a:ext cx="1819249" cy="274320"/>
           </a:xfrm>
           <a:prstGeom prst="rect">
@@ -5624,13 +6425,13 @@
       </p:sp>
       <p:sp>
         <p:nvSpPr>
-          <p:cNvPr id="27" name="TextBox 26"/>
-          <p:cNvSpPr txBox="1"/>
-          <p:nvPr/>
-        </p:nvSpPr>
-        <p:spPr>
-          <a:xfrm>
-            <a:off x="548640" y="3657600"/>
+          <p:cNvPr id="46" name="TextBox 45"/>
+          <p:cNvSpPr txBox="1"/>
+          <p:nvPr/>
+        </p:nvSpPr>
+        <p:spPr>
+          <a:xfrm>
+            <a:off x="548640" y="4114800"/>
             <a:ext cx="1463040" cy="274320"/>
           </a:xfrm>
           <a:prstGeom prst="rect">
@@ -5663,13 +6464,13 @@
       </p:sp>
       <p:sp>
         <p:nvSpPr>
-          <p:cNvPr id="28" name="TextBox 27"/>
-          <p:cNvSpPr txBox="1"/>
-          <p:nvPr/>
-        </p:nvSpPr>
-        <p:spPr>
-          <a:xfrm>
-            <a:off x="548640" y="3858768"/>
+          <p:cNvPr id="47" name="TextBox 46"/>
+          <p:cNvSpPr txBox="1"/>
+          <p:nvPr/>
+        </p:nvSpPr>
+        <p:spPr>
+          <a:xfrm>
+            <a:off x="548640" y="4315968"/>
             <a:ext cx="1463040" cy="219456"/>
           </a:xfrm>
           <a:prstGeom prst="rect">
@@ -5702,13 +6503,13 @@
       </p:sp>
       <p:sp>
         <p:nvSpPr>
-          <p:cNvPr id="29" name="Rounded Rectangle 28"/>
+          <p:cNvPr id="48" name="Rounded Rectangle 47"/>
           <p:cNvSpPr/>
           <p:nvPr/>
         </p:nvSpPr>
         <p:spPr>
           <a:xfrm>
-            <a:off x="7158364" y="3657600"/>
+            <a:off x="7158364" y="4114800"/>
             <a:ext cx="2969419" cy="347472"/>
           </a:xfrm>
           <a:prstGeom prst="roundRect">
@@ -5748,13 +6549,13 @@
       </p:sp>
       <p:sp>
         <p:nvSpPr>
-          <p:cNvPr id="30" name="TextBox 29"/>
-          <p:cNvSpPr txBox="1"/>
-          <p:nvPr/>
-        </p:nvSpPr>
-        <p:spPr>
-          <a:xfrm>
-            <a:off x="7268092" y="3685032"/>
+          <p:cNvPr id="49" name="TextBox 48"/>
+          <p:cNvSpPr txBox="1"/>
+          <p:nvPr/>
+        </p:nvSpPr>
+        <p:spPr>
+          <a:xfrm>
+            <a:off x="7268092" y="4142232"/>
             <a:ext cx="2749963" cy="274320"/>
           </a:xfrm>
           <a:prstGeom prst="rect">
@@ -5787,13 +6588,13 @@
       </p:sp>
       <p:sp>
         <p:nvSpPr>
-          <p:cNvPr id="31" name="TextBox 30"/>
-          <p:cNvSpPr txBox="1"/>
-          <p:nvPr/>
-        </p:nvSpPr>
-        <p:spPr>
-          <a:xfrm>
-            <a:off x="548640" y="4306824"/>
+          <p:cNvPr id="50" name="TextBox 49"/>
+          <p:cNvSpPr txBox="1"/>
+          <p:nvPr/>
+        </p:nvSpPr>
+        <p:spPr>
+          <a:xfrm>
+            <a:off x="548640" y="4764024"/>
             <a:ext cx="1463040" cy="274320"/>
           </a:xfrm>
           <a:prstGeom prst="rect">
@@ -5826,13 +6627,13 @@
       </p:sp>
       <p:sp>
         <p:nvSpPr>
-          <p:cNvPr id="32" name="TextBox 31"/>
-          <p:cNvSpPr txBox="1"/>
-          <p:nvPr/>
-        </p:nvSpPr>
-        <p:spPr>
-          <a:xfrm>
-            <a:off x="548640" y="4507992"/>
+          <p:cNvPr id="51" name="TextBox 50"/>
+          <p:cNvSpPr txBox="1"/>
+          <p:nvPr/>
+        </p:nvSpPr>
+        <p:spPr>
+          <a:xfrm>
+            <a:off x="548640" y="4965192"/>
             <a:ext cx="1463040" cy="219456"/>
           </a:xfrm>
           <a:prstGeom prst="rect">
@@ -5865,13 +6666,13 @@
       </p:sp>
       <p:sp>
         <p:nvSpPr>
-          <p:cNvPr id="33" name="Rounded Rectangle 32"/>
+          <p:cNvPr id="52" name="Rounded Rectangle 51"/>
           <p:cNvSpPr/>
           <p:nvPr/>
         </p:nvSpPr>
         <p:spPr>
           <a:xfrm>
-            <a:off x="10260742" y="4306824"/>
+            <a:off x="10260742" y="4764024"/>
             <a:ext cx="1107993" cy="347472"/>
           </a:xfrm>
           <a:prstGeom prst="roundRect">
@@ -5911,13 +6712,13 @@
       </p:sp>
       <p:sp>
         <p:nvSpPr>
-          <p:cNvPr id="34" name="TextBox 33"/>
-          <p:cNvSpPr txBox="1"/>
-          <p:nvPr/>
-        </p:nvSpPr>
-        <p:spPr>
-          <a:xfrm>
-            <a:off x="10370470" y="4334256"/>
+          <p:cNvPr id="53" name="TextBox 52"/>
+          <p:cNvSpPr txBox="1"/>
+          <p:nvPr/>
+        </p:nvSpPr>
+        <p:spPr>
+          <a:xfrm>
+            <a:off x="10370470" y="4791456"/>
             <a:ext cx="888537" cy="274320"/>
           </a:xfrm>
           <a:prstGeom prst="rect">
@@ -5950,7 +6751,7 @@
       </p:sp>
       <p:cxnSp>
         <p:nvCxnSpPr>
-          <p:cNvPr id="35" name="Connector 34"/>
+          <p:cNvPr id="54" name="Connector 53"/>
           <p:cNvCxnSpPr/>
           <p:nvPr/>
         </p:nvCxnSpPr>
@@ -5987,7 +6788,7 @@
       </p:cxnSp>
       <p:sp>
         <p:nvSpPr>
-          <p:cNvPr id="36" name="TextBox 35"/>
+          <p:cNvPr id="55" name="TextBox 54"/>
           <p:cNvSpPr txBox="1"/>
           <p:nvPr/>
         </p:nvSpPr>
@@ -6026,7 +6827,7 @@
       </p:sp>
       <p:cxnSp>
         <p:nvCxnSpPr>
-          <p:cNvPr id="37" name="Connector 36"/>
+          <p:cNvPr id="56" name="Connector 55"/>
           <p:cNvCxnSpPr/>
           <p:nvPr/>
         </p:nvCxnSpPr>
@@ -6062,7 +6863,7 @@
       </p:cxnSp>
       <p:pic>
         <p:nvPicPr>
-          <p:cNvPr id="38" name="Picture 37" descr="acme-logo.png"/>
+          <p:cNvPr id="57" name="Picture 56" descr="acme-logo.png"/>
           <p:cNvPicPr>
             <a:picLocks noChangeAspect="1"/>
           </p:cNvPicPr>
@@ -6086,7 +6887,7 @@
       </p:pic>
       <p:sp>
         <p:nvSpPr>
-          <p:cNvPr id="39" name="TextBox 38"/>
+          <p:cNvPr id="58" name="TextBox 57"/>
           <p:cNvSpPr txBox="1"/>
           <p:nvPr/>
         </p:nvSpPr>
@@ -6125,7 +6926,7 @@
       </p:sp>
       <p:sp>
         <p:nvSpPr>
-          <p:cNvPr id="40" name="TextBox 39"/>
+          <p:cNvPr id="59" name="TextBox 58"/>
           <p:cNvSpPr txBox="1"/>
           <p:nvPr/>
         </p:nvSpPr>
@@ -6799,8 +7600,809 @@
         </p:nvSpPr>
         <p:spPr>
           <a:xfrm>
-            <a:off x="548640" y="1920240"/>
-            <a:ext cx="2286000" cy="298486"/>
+            <a:off x="548640" y="1956816"/>
+            <a:ext cx="2286000" cy="182880"/>
+          </a:xfrm>
+          <a:prstGeom prst="rect">
+            <a:avLst/>
+          </a:prstGeom>
+          <a:noFill/>
+        </p:spPr>
+        <p:txBody>
+          <a:bodyPr wrap="square" lIns="0" rIns="0" tIns="0" bIns="0" anchor="t">
+            <a:spAutoFit/>
+          </a:bodyPr>
+          <a:lstStyle/>
+          <a:p>
+            <a:pPr algn="l">
+              <a:lnSpc>
+                <a:spcPct val="115000"/>
+              </a:lnSpc>
+            </a:pPr>
+            <a:r>
+              <a:rPr sz="750" b="1" i="0">
+                <a:solidFill>
+                  <a:srgbClr val="8A8A8A"/>
+                </a:solidFill>
+                <a:latin typeface="Calibri"/>
+              </a:rPr>
+              <a:t>MILESTONES</a:t>
+            </a:r>
+          </a:p>
+        </p:txBody>
+      </p:sp>
+      <p:sp>
+        <p:nvSpPr>
+          <p:cNvPr id="19" name="Diamond 18"/>
+          <p:cNvSpPr/>
+          <p:nvPr/>
+        </p:nvSpPr>
+        <p:spPr>
+          <a:xfrm>
+            <a:off x="3971256" y="2084832"/>
+            <a:ext cx="109728" cy="109728"/>
+          </a:xfrm>
+          <a:prstGeom prst="diamond">
+            <a:avLst/>
+          </a:prstGeom>
+          <a:solidFill>
+            <a:srgbClr val="3F7A52"/>
+          </a:solidFill>
+          <a:ln w="9525">
+            <a:solidFill>
+              <a:srgbClr val="FFFFFF"/>
+            </a:solidFill>
+          </a:ln>
+          <a:effectLst/>
+        </p:spPr>
+        <p:style>
+          <a:lnRef idx="1">
+            <a:schemeClr val="accent1"/>
+          </a:lnRef>
+          <a:fillRef idx="3">
+            <a:schemeClr val="accent1"/>
+          </a:fillRef>
+          <a:effectRef idx="2">
+            <a:schemeClr val="accent1"/>
+          </a:effectRef>
+          <a:fontRef idx="minor">
+            <a:schemeClr val="lt1"/>
+          </a:fontRef>
+        </p:style>
+        <p:txBody>
+          <a:bodyPr rtlCol="0" anchor="ctr"/>
+          <a:lstStyle/>
+          <a:p>
+            <a:pPr algn="ctr"/>
+          </a:p>
+        </p:txBody>
+      </p:sp>
+      <p:sp>
+        <p:nvSpPr>
+          <p:cNvPr id="20" name="TextBox 19"/>
+          <p:cNvSpPr txBox="1"/>
+          <p:nvPr/>
+        </p:nvSpPr>
+        <p:spPr>
+          <a:xfrm>
+            <a:off x="3614640" y="2212848"/>
+            <a:ext cx="822959" cy="164592"/>
+          </a:xfrm>
+          <a:prstGeom prst="rect">
+            <a:avLst/>
+          </a:prstGeom>
+          <a:noFill/>
+        </p:spPr>
+        <p:txBody>
+          <a:bodyPr wrap="square" lIns="0" rIns="0" tIns="0" bIns="0" anchor="t">
+            <a:spAutoFit/>
+          </a:bodyPr>
+          <a:lstStyle/>
+          <a:p>
+            <a:pPr algn="ctr">
+              <a:lnSpc>
+                <a:spcPct val="115000"/>
+              </a:lnSpc>
+            </a:pPr>
+            <a:r>
+              <a:rPr sz="750" b="0" i="0">
+                <a:solidFill>
+                  <a:srgbClr val="4A4A4A"/>
+                </a:solidFill>
+                <a:latin typeface="Calibri"/>
+              </a:rPr>
+              <a:t>27 Mar</a:t>
+            </a:r>
+          </a:p>
+        </p:txBody>
+      </p:sp>
+      <p:sp>
+        <p:nvSpPr>
+          <p:cNvPr id="21" name="Diamond 20"/>
+          <p:cNvSpPr/>
+          <p:nvPr/>
+        </p:nvSpPr>
+        <p:spPr>
+          <a:xfrm>
+            <a:off x="4818481" y="2084832"/>
+            <a:ext cx="109728" cy="109728"/>
+          </a:xfrm>
+          <a:prstGeom prst="diamond">
+            <a:avLst/>
+          </a:prstGeom>
+          <a:solidFill>
+            <a:srgbClr val="3F7A52"/>
+          </a:solidFill>
+          <a:ln w="9525">
+            <a:solidFill>
+              <a:srgbClr val="FFFFFF"/>
+            </a:solidFill>
+          </a:ln>
+          <a:effectLst/>
+        </p:spPr>
+        <p:style>
+          <a:lnRef idx="1">
+            <a:schemeClr val="accent1"/>
+          </a:lnRef>
+          <a:fillRef idx="3">
+            <a:schemeClr val="accent1"/>
+          </a:fillRef>
+          <a:effectRef idx="2">
+            <a:schemeClr val="accent1"/>
+          </a:effectRef>
+          <a:fontRef idx="minor">
+            <a:schemeClr val="lt1"/>
+          </a:fontRef>
+        </p:style>
+        <p:txBody>
+          <a:bodyPr rtlCol="0" anchor="ctr"/>
+          <a:lstStyle/>
+          <a:p>
+            <a:pPr algn="ctr"/>
+          </a:p>
+        </p:txBody>
+      </p:sp>
+      <p:sp>
+        <p:nvSpPr>
+          <p:cNvPr id="22" name="TextBox 21"/>
+          <p:cNvSpPr txBox="1"/>
+          <p:nvPr/>
+        </p:nvSpPr>
+        <p:spPr>
+          <a:xfrm>
+            <a:off x="4461865" y="1901952"/>
+            <a:ext cx="822959" cy="164592"/>
+          </a:xfrm>
+          <a:prstGeom prst="rect">
+            <a:avLst/>
+          </a:prstGeom>
+          <a:noFill/>
+        </p:spPr>
+        <p:txBody>
+          <a:bodyPr wrap="square" lIns="0" rIns="0" tIns="0" bIns="0" anchor="t">
+            <a:spAutoFit/>
+          </a:bodyPr>
+          <a:lstStyle/>
+          <a:p>
+            <a:pPr algn="ctr">
+              <a:lnSpc>
+                <a:spcPct val="115000"/>
+              </a:lnSpc>
+            </a:pPr>
+            <a:r>
+              <a:rPr sz="750" b="0" i="0">
+                <a:solidFill>
+                  <a:srgbClr val="4A4A4A"/>
+                </a:solidFill>
+                <a:latin typeface="Calibri"/>
+              </a:rPr>
+              <a:t>17 Apr</a:t>
+            </a:r>
+          </a:p>
+        </p:txBody>
+      </p:sp>
+      <p:sp>
+        <p:nvSpPr>
+          <p:cNvPr id="23" name="Diamond 22"/>
+          <p:cNvSpPr/>
+          <p:nvPr/>
+        </p:nvSpPr>
+        <p:spPr>
+          <a:xfrm>
+            <a:off x="5342953" y="2084832"/>
+            <a:ext cx="109728" cy="109728"/>
+          </a:xfrm>
+          <a:prstGeom prst="diamond">
+            <a:avLst/>
+          </a:prstGeom>
+          <a:solidFill>
+            <a:srgbClr val="AE7A2A"/>
+          </a:solidFill>
+          <a:ln w="9525">
+            <a:solidFill>
+              <a:srgbClr val="FFFFFF"/>
+            </a:solidFill>
+          </a:ln>
+          <a:effectLst/>
+        </p:spPr>
+        <p:style>
+          <a:lnRef idx="1">
+            <a:schemeClr val="accent1"/>
+          </a:lnRef>
+          <a:fillRef idx="3">
+            <a:schemeClr val="accent1"/>
+          </a:fillRef>
+          <a:effectRef idx="2">
+            <a:schemeClr val="accent1"/>
+          </a:effectRef>
+          <a:fontRef idx="minor">
+            <a:schemeClr val="lt1"/>
+          </a:fontRef>
+        </p:style>
+        <p:txBody>
+          <a:bodyPr rtlCol="0" anchor="ctr"/>
+          <a:lstStyle/>
+          <a:p>
+            <a:pPr algn="ctr"/>
+          </a:p>
+        </p:txBody>
+      </p:sp>
+      <p:sp>
+        <p:nvSpPr>
+          <p:cNvPr id="24" name="TextBox 23"/>
+          <p:cNvSpPr txBox="1"/>
+          <p:nvPr/>
+        </p:nvSpPr>
+        <p:spPr>
+          <a:xfrm>
+            <a:off x="4986337" y="2212848"/>
+            <a:ext cx="822959" cy="164592"/>
+          </a:xfrm>
+          <a:prstGeom prst="rect">
+            <a:avLst/>
+          </a:prstGeom>
+          <a:noFill/>
+        </p:spPr>
+        <p:txBody>
+          <a:bodyPr wrap="square" lIns="0" rIns="0" tIns="0" bIns="0" anchor="t">
+            <a:spAutoFit/>
+          </a:bodyPr>
+          <a:lstStyle/>
+          <a:p>
+            <a:pPr algn="ctr">
+              <a:lnSpc>
+                <a:spcPct val="115000"/>
+              </a:lnSpc>
+            </a:pPr>
+            <a:r>
+              <a:rPr sz="750" b="0" i="0">
+                <a:solidFill>
+                  <a:srgbClr val="4A4A4A"/>
+                </a:solidFill>
+                <a:latin typeface="Calibri"/>
+              </a:rPr>
+              <a:t>30 Apr</a:t>
+            </a:r>
+          </a:p>
+        </p:txBody>
+      </p:sp>
+      <p:sp>
+        <p:nvSpPr>
+          <p:cNvPr id="25" name="Diamond 24"/>
+          <p:cNvSpPr/>
+          <p:nvPr/>
+        </p:nvSpPr>
+        <p:spPr>
+          <a:xfrm>
+            <a:off x="5383298" y="2084832"/>
+            <a:ext cx="109728" cy="109728"/>
+          </a:xfrm>
+          <a:prstGeom prst="diamond">
+            <a:avLst/>
+          </a:prstGeom>
+          <a:solidFill>
+            <a:srgbClr val="3F7A52"/>
+          </a:solidFill>
+          <a:ln w="9525">
+            <a:solidFill>
+              <a:srgbClr val="FFFFFF"/>
+            </a:solidFill>
+          </a:ln>
+          <a:effectLst/>
+        </p:spPr>
+        <p:style>
+          <a:lnRef idx="1">
+            <a:schemeClr val="accent1"/>
+          </a:lnRef>
+          <a:fillRef idx="3">
+            <a:schemeClr val="accent1"/>
+          </a:fillRef>
+          <a:effectRef idx="2">
+            <a:schemeClr val="accent1"/>
+          </a:effectRef>
+          <a:fontRef idx="minor">
+            <a:schemeClr val="lt1"/>
+          </a:fontRef>
+        </p:style>
+        <p:txBody>
+          <a:bodyPr rtlCol="0" anchor="ctr"/>
+          <a:lstStyle/>
+          <a:p>
+            <a:pPr algn="ctr"/>
+          </a:p>
+        </p:txBody>
+      </p:sp>
+      <p:sp>
+        <p:nvSpPr>
+          <p:cNvPr id="26" name="Diamond 25"/>
+          <p:cNvSpPr/>
+          <p:nvPr/>
+        </p:nvSpPr>
+        <p:spPr>
+          <a:xfrm>
+            <a:off x="5665706" y="2084832"/>
+            <a:ext cx="109728" cy="109728"/>
+          </a:xfrm>
+          <a:prstGeom prst="diamond">
+            <a:avLst/>
+          </a:prstGeom>
+          <a:solidFill>
+            <a:srgbClr val="3F7A52"/>
+          </a:solidFill>
+          <a:ln w="9525">
+            <a:solidFill>
+              <a:srgbClr val="FFFFFF"/>
+            </a:solidFill>
+          </a:ln>
+          <a:effectLst/>
+        </p:spPr>
+        <p:style>
+          <a:lnRef idx="1">
+            <a:schemeClr val="accent1"/>
+          </a:lnRef>
+          <a:fillRef idx="3">
+            <a:schemeClr val="accent1"/>
+          </a:fillRef>
+          <a:effectRef idx="2">
+            <a:schemeClr val="accent1"/>
+          </a:effectRef>
+          <a:fontRef idx="minor">
+            <a:schemeClr val="lt1"/>
+          </a:fontRef>
+        </p:style>
+        <p:txBody>
+          <a:bodyPr rtlCol="0" anchor="ctr"/>
+          <a:lstStyle/>
+          <a:p>
+            <a:pPr algn="ctr"/>
+          </a:p>
+        </p:txBody>
+      </p:sp>
+      <p:sp>
+        <p:nvSpPr>
+          <p:cNvPr id="27" name="TextBox 26"/>
+          <p:cNvSpPr txBox="1"/>
+          <p:nvPr/>
+        </p:nvSpPr>
+        <p:spPr>
+          <a:xfrm>
+            <a:off x="5377670" y="1901952"/>
+            <a:ext cx="685800" cy="164592"/>
+          </a:xfrm>
+          <a:prstGeom prst="rect">
+            <a:avLst/>
+          </a:prstGeom>
+          <a:noFill/>
+        </p:spPr>
+        <p:txBody>
+          <a:bodyPr wrap="square" lIns="0" rIns="0" tIns="0" bIns="0" anchor="t">
+            <a:spAutoFit/>
+          </a:bodyPr>
+          <a:lstStyle/>
+          <a:p>
+            <a:pPr algn="ctr">
+              <a:lnSpc>
+                <a:spcPct val="115000"/>
+              </a:lnSpc>
+            </a:pPr>
+            <a:r>
+              <a:rPr sz="750" b="0" i="0">
+                <a:solidFill>
+                  <a:srgbClr val="4A4A4A"/>
+                </a:solidFill>
+                <a:latin typeface="Calibri"/>
+              </a:rPr>
+              <a:t>8 May</a:t>
+            </a:r>
+          </a:p>
+        </p:txBody>
+      </p:sp>
+      <p:sp>
+        <p:nvSpPr>
+          <p:cNvPr id="28" name="Diamond 27"/>
+          <p:cNvSpPr/>
+          <p:nvPr/>
+        </p:nvSpPr>
+        <p:spPr>
+          <a:xfrm>
+            <a:off x="7360155" y="2084832"/>
+            <a:ext cx="109728" cy="109728"/>
+          </a:xfrm>
+          <a:prstGeom prst="diamond">
+            <a:avLst/>
+          </a:prstGeom>
+          <a:solidFill>
+            <a:srgbClr val="3F7A52"/>
+          </a:solidFill>
+          <a:ln w="9525">
+            <a:solidFill>
+              <a:srgbClr val="FFFFFF"/>
+            </a:solidFill>
+          </a:ln>
+          <a:effectLst/>
+        </p:spPr>
+        <p:style>
+          <a:lnRef idx="1">
+            <a:schemeClr val="accent1"/>
+          </a:lnRef>
+          <a:fillRef idx="3">
+            <a:schemeClr val="accent1"/>
+          </a:fillRef>
+          <a:effectRef idx="2">
+            <a:schemeClr val="accent1"/>
+          </a:effectRef>
+          <a:fontRef idx="minor">
+            <a:schemeClr val="lt1"/>
+          </a:fontRef>
+        </p:style>
+        <p:txBody>
+          <a:bodyPr rtlCol="0" anchor="ctr"/>
+          <a:lstStyle/>
+          <a:p>
+            <a:pPr algn="ctr"/>
+          </a:p>
+        </p:txBody>
+      </p:sp>
+      <p:sp>
+        <p:nvSpPr>
+          <p:cNvPr id="29" name="TextBox 28"/>
+          <p:cNvSpPr txBox="1"/>
+          <p:nvPr/>
+        </p:nvSpPr>
+        <p:spPr>
+          <a:xfrm>
+            <a:off x="7003539" y="2212848"/>
+            <a:ext cx="822959" cy="164592"/>
+          </a:xfrm>
+          <a:prstGeom prst="rect">
+            <a:avLst/>
+          </a:prstGeom>
+          <a:noFill/>
+        </p:spPr>
+        <p:txBody>
+          <a:bodyPr wrap="square" lIns="0" rIns="0" tIns="0" bIns="0" anchor="t">
+            <a:spAutoFit/>
+          </a:bodyPr>
+          <a:lstStyle/>
+          <a:p>
+            <a:pPr algn="ctr">
+              <a:lnSpc>
+                <a:spcPct val="115000"/>
+              </a:lnSpc>
+            </a:pPr>
+            <a:r>
+              <a:rPr sz="750" b="0" i="0">
+                <a:solidFill>
+                  <a:srgbClr val="4A4A4A"/>
+                </a:solidFill>
+                <a:latin typeface="Calibri"/>
+              </a:rPr>
+              <a:t>19 Jun</a:t>
+            </a:r>
+          </a:p>
+        </p:txBody>
+      </p:sp>
+      <p:sp>
+        <p:nvSpPr>
+          <p:cNvPr id="30" name="Diamond 29"/>
+          <p:cNvSpPr/>
+          <p:nvPr/>
+        </p:nvSpPr>
+        <p:spPr>
+          <a:xfrm>
+            <a:off x="8772196" y="2084832"/>
+            <a:ext cx="109728" cy="109728"/>
+          </a:xfrm>
+          <a:prstGeom prst="diamond">
+            <a:avLst/>
+          </a:prstGeom>
+          <a:solidFill>
+            <a:srgbClr val="3F7A52"/>
+          </a:solidFill>
+          <a:ln w="9525">
+            <a:solidFill>
+              <a:srgbClr val="FFFFFF"/>
+            </a:solidFill>
+          </a:ln>
+          <a:effectLst/>
+        </p:spPr>
+        <p:style>
+          <a:lnRef idx="1">
+            <a:schemeClr val="accent1"/>
+          </a:lnRef>
+          <a:fillRef idx="3">
+            <a:schemeClr val="accent1"/>
+          </a:fillRef>
+          <a:effectRef idx="2">
+            <a:schemeClr val="accent1"/>
+          </a:effectRef>
+          <a:fontRef idx="minor">
+            <a:schemeClr val="lt1"/>
+          </a:fontRef>
+        </p:style>
+        <p:txBody>
+          <a:bodyPr rtlCol="0" anchor="ctr"/>
+          <a:lstStyle/>
+          <a:p>
+            <a:pPr algn="ctr"/>
+          </a:p>
+        </p:txBody>
+      </p:sp>
+      <p:sp>
+        <p:nvSpPr>
+          <p:cNvPr id="31" name="TextBox 30"/>
+          <p:cNvSpPr txBox="1"/>
+          <p:nvPr/>
+        </p:nvSpPr>
+        <p:spPr>
+          <a:xfrm>
+            <a:off x="8415580" y="2212848"/>
+            <a:ext cx="822959" cy="164592"/>
+          </a:xfrm>
+          <a:prstGeom prst="rect">
+            <a:avLst/>
+          </a:prstGeom>
+          <a:noFill/>
+        </p:spPr>
+        <p:txBody>
+          <a:bodyPr wrap="square" lIns="0" rIns="0" tIns="0" bIns="0" anchor="t">
+            <a:spAutoFit/>
+          </a:bodyPr>
+          <a:lstStyle/>
+          <a:p>
+            <a:pPr algn="ctr">
+              <a:lnSpc>
+                <a:spcPct val="115000"/>
+              </a:lnSpc>
+            </a:pPr>
+            <a:r>
+              <a:rPr sz="750" b="0" i="0">
+                <a:solidFill>
+                  <a:srgbClr val="4A4A4A"/>
+                </a:solidFill>
+                <a:latin typeface="Calibri"/>
+              </a:rPr>
+              <a:t>24 Jul</a:t>
+            </a:r>
+          </a:p>
+        </p:txBody>
+      </p:sp>
+      <p:sp>
+        <p:nvSpPr>
+          <p:cNvPr id="32" name="Diamond 31"/>
+          <p:cNvSpPr/>
+          <p:nvPr/>
+        </p:nvSpPr>
+        <p:spPr>
+          <a:xfrm>
+            <a:off x="10910430" y="2084832"/>
+            <a:ext cx="109728" cy="109728"/>
+          </a:xfrm>
+          <a:prstGeom prst="diamond">
+            <a:avLst/>
+          </a:prstGeom>
+          <a:solidFill>
+            <a:srgbClr val="3F7A52"/>
+          </a:solidFill>
+          <a:ln w="9525">
+            <a:solidFill>
+              <a:srgbClr val="FFFFFF"/>
+            </a:solidFill>
+          </a:ln>
+          <a:effectLst/>
+        </p:spPr>
+        <p:style>
+          <a:lnRef idx="1">
+            <a:schemeClr val="accent1"/>
+          </a:lnRef>
+          <a:fillRef idx="3">
+            <a:schemeClr val="accent1"/>
+          </a:fillRef>
+          <a:effectRef idx="2">
+            <a:schemeClr val="accent1"/>
+          </a:effectRef>
+          <a:fontRef idx="minor">
+            <a:schemeClr val="lt1"/>
+          </a:fontRef>
+        </p:style>
+        <p:txBody>
+          <a:bodyPr rtlCol="0" anchor="ctr"/>
+          <a:lstStyle/>
+          <a:p>
+            <a:pPr algn="ctr"/>
+          </a:p>
+        </p:txBody>
+      </p:sp>
+      <p:sp>
+        <p:nvSpPr>
+          <p:cNvPr id="33" name="TextBox 32"/>
+          <p:cNvSpPr txBox="1"/>
+          <p:nvPr/>
+        </p:nvSpPr>
+        <p:spPr>
+          <a:xfrm>
+            <a:off x="10553814" y="2212848"/>
+            <a:ext cx="822959" cy="164592"/>
+          </a:xfrm>
+          <a:prstGeom prst="rect">
+            <a:avLst/>
+          </a:prstGeom>
+          <a:noFill/>
+        </p:spPr>
+        <p:txBody>
+          <a:bodyPr wrap="square" lIns="0" rIns="0" tIns="0" bIns="0" anchor="t">
+            <a:spAutoFit/>
+          </a:bodyPr>
+          <a:lstStyle/>
+          <a:p>
+            <a:pPr algn="ctr">
+              <a:lnSpc>
+                <a:spcPct val="115000"/>
+              </a:lnSpc>
+            </a:pPr>
+            <a:r>
+              <a:rPr sz="750" b="0" i="0">
+                <a:solidFill>
+                  <a:srgbClr val="4A4A4A"/>
+                </a:solidFill>
+                <a:latin typeface="Calibri"/>
+              </a:rPr>
+              <a:t>15 Sep</a:t>
+            </a:r>
+          </a:p>
+        </p:txBody>
+      </p:sp>
+      <p:sp>
+        <p:nvSpPr>
+          <p:cNvPr id="34" name="Diamond 33"/>
+          <p:cNvSpPr/>
+          <p:nvPr/>
+        </p:nvSpPr>
+        <p:spPr>
+          <a:xfrm>
+            <a:off x="11313871" y="2084832"/>
+            <a:ext cx="109728" cy="109728"/>
+          </a:xfrm>
+          <a:prstGeom prst="diamond">
+            <a:avLst/>
+          </a:prstGeom>
+          <a:solidFill>
+            <a:srgbClr val="3F7A52"/>
+          </a:solidFill>
+          <a:ln w="9525">
+            <a:solidFill>
+              <a:srgbClr val="FFFFFF"/>
+            </a:solidFill>
+          </a:ln>
+          <a:effectLst/>
+        </p:spPr>
+        <p:style>
+          <a:lnRef idx="1">
+            <a:schemeClr val="accent1"/>
+          </a:lnRef>
+          <a:fillRef idx="3">
+            <a:schemeClr val="accent1"/>
+          </a:fillRef>
+          <a:effectRef idx="2">
+            <a:schemeClr val="accent1"/>
+          </a:effectRef>
+          <a:fontRef idx="minor">
+            <a:schemeClr val="lt1"/>
+          </a:fontRef>
+        </p:style>
+        <p:txBody>
+          <a:bodyPr rtlCol="0" anchor="ctr"/>
+          <a:lstStyle/>
+          <a:p>
+            <a:pPr algn="ctr"/>
+          </a:p>
+        </p:txBody>
+      </p:sp>
+      <p:sp>
+        <p:nvSpPr>
+          <p:cNvPr id="35" name="TextBox 34"/>
+          <p:cNvSpPr txBox="1"/>
+          <p:nvPr/>
+        </p:nvSpPr>
+        <p:spPr>
+          <a:xfrm>
+            <a:off x="10957255" y="1901952"/>
+            <a:ext cx="822959" cy="164592"/>
+          </a:xfrm>
+          <a:prstGeom prst="rect">
+            <a:avLst/>
+          </a:prstGeom>
+          <a:noFill/>
+        </p:spPr>
+        <p:txBody>
+          <a:bodyPr wrap="square" lIns="0" rIns="0" tIns="0" bIns="0" anchor="t">
+            <a:spAutoFit/>
+          </a:bodyPr>
+          <a:lstStyle/>
+          <a:p>
+            <a:pPr algn="ctr">
+              <a:lnSpc>
+                <a:spcPct val="115000"/>
+              </a:lnSpc>
+            </a:pPr>
+            <a:r>
+              <a:rPr sz="750" b="0" i="0">
+                <a:solidFill>
+                  <a:srgbClr val="4A4A4A"/>
+                </a:solidFill>
+                <a:latin typeface="Calibri"/>
+              </a:rPr>
+              <a:t>25 Sep</a:t>
+            </a:r>
+          </a:p>
+        </p:txBody>
+      </p:sp>
+      <p:cxnSp>
+        <p:nvCxnSpPr>
+          <p:cNvPr id="36" name="Connector 35"/>
+          <p:cNvCxnSpPr/>
+          <p:nvPr/>
+        </p:nvCxnSpPr>
+        <p:spPr>
+          <a:xfrm>
+            <a:off x="3017520" y="2322576"/>
+            <a:ext cx="8351215" cy="0"/>
+          </a:xfrm>
+          <a:prstGeom prst="line">
+            <a:avLst/>
+          </a:prstGeom>
+          <a:ln w="5080">
+            <a:solidFill>
+              <a:srgbClr val="EFEFEF"/>
+            </a:solidFill>
+          </a:ln>
+          <a:effectLst/>
+        </p:spPr>
+        <p:style>
+          <a:lnRef idx="2">
+            <a:schemeClr val="accent1"/>
+          </a:lnRef>
+          <a:fillRef idx="0">
+            <a:schemeClr val="accent1"/>
+          </a:fillRef>
+          <a:effectRef idx="1">
+            <a:schemeClr val="accent1"/>
+          </a:effectRef>
+          <a:fontRef idx="minor">
+            <a:schemeClr val="tx1"/>
+          </a:fontRef>
+        </p:style>
+      </p:cxnSp>
+      <p:sp>
+        <p:nvSpPr>
+          <p:cNvPr id="37" name="TextBox 36"/>
+          <p:cNvSpPr txBox="1"/>
+          <p:nvPr/>
+        </p:nvSpPr>
+        <p:spPr>
+          <a:xfrm>
+            <a:off x="548640" y="2304288"/>
+            <a:ext cx="2286000" cy="316230"/>
           </a:xfrm>
           <a:prstGeom prst="rect">
             <a:avLst/>
@@ -6832,14 +8434,14 @@
       </p:sp>
       <p:sp>
         <p:nvSpPr>
-          <p:cNvPr id="19" name="TextBox 18"/>
-          <p:cNvSpPr txBox="1"/>
-          <p:nvPr/>
-        </p:nvSpPr>
-        <p:spPr>
-          <a:xfrm>
-            <a:off x="2148840" y="1920240"/>
-            <a:ext cx="822960" cy="298486"/>
+          <p:cNvPr id="38" name="TextBox 37"/>
+          <p:cNvSpPr txBox="1"/>
+          <p:nvPr/>
+        </p:nvSpPr>
+        <p:spPr>
+          <a:xfrm>
+            <a:off x="2148840" y="2304288"/>
+            <a:ext cx="822960" cy="316230"/>
           </a:xfrm>
           <a:prstGeom prst="rect">
             <a:avLst/>
@@ -6871,13 +8473,13 @@
       </p:sp>
       <p:sp>
         <p:nvSpPr>
-          <p:cNvPr id="20" name="Rounded Rectangle 19"/>
+          <p:cNvPr id="39" name="Rounded Rectangle 38"/>
           <p:cNvSpPr/>
           <p:nvPr/>
         </p:nvSpPr>
         <p:spPr>
           <a:xfrm>
-            <a:off x="3017520" y="1978043"/>
+            <a:off x="3017520" y="2370963"/>
             <a:ext cx="443784" cy="182880"/>
           </a:xfrm>
           <a:prstGeom prst="roundRect">
@@ -6917,13 +8519,13 @@
       </p:sp>
       <p:sp>
         <p:nvSpPr>
-          <p:cNvPr id="21" name="Rounded Rectangle 20"/>
+          <p:cNvPr id="40" name="Rounded Rectangle 39"/>
           <p:cNvSpPr/>
           <p:nvPr/>
         </p:nvSpPr>
         <p:spPr>
           <a:xfrm>
-            <a:off x="3017520" y="1978043"/>
+            <a:off x="3017520" y="2370963"/>
             <a:ext cx="443784" cy="182880"/>
           </a:xfrm>
           <a:prstGeom prst="roundRect">
@@ -6963,14 +8565,14 @@
       </p:sp>
       <p:sp>
         <p:nvSpPr>
-          <p:cNvPr id="22" name="TextBox 21"/>
-          <p:cNvSpPr txBox="1"/>
-          <p:nvPr/>
-        </p:nvSpPr>
-        <p:spPr>
-          <a:xfrm>
-            <a:off x="548640" y="2218726"/>
-            <a:ext cx="2286000" cy="298486"/>
+          <p:cNvPr id="41" name="TextBox 40"/>
+          <p:cNvSpPr txBox="1"/>
+          <p:nvPr/>
+        </p:nvSpPr>
+        <p:spPr>
+          <a:xfrm>
+            <a:off x="548640" y="2620518"/>
+            <a:ext cx="2286000" cy="316230"/>
           </a:xfrm>
           <a:prstGeom prst="rect">
             <a:avLst/>
@@ -7002,14 +8604,14 @@
       </p:sp>
       <p:sp>
         <p:nvSpPr>
-          <p:cNvPr id="23" name="TextBox 22"/>
-          <p:cNvSpPr txBox="1"/>
-          <p:nvPr/>
-        </p:nvSpPr>
-        <p:spPr>
-          <a:xfrm>
-            <a:off x="2148840" y="2218726"/>
-            <a:ext cx="822960" cy="298486"/>
+          <p:cNvPr id="42" name="TextBox 41"/>
+          <p:cNvSpPr txBox="1"/>
+          <p:nvPr/>
+        </p:nvSpPr>
+        <p:spPr>
+          <a:xfrm>
+            <a:off x="2148840" y="2620518"/>
+            <a:ext cx="822960" cy="316230"/>
           </a:xfrm>
           <a:prstGeom prst="rect">
             <a:avLst/>
@@ -7041,13 +8643,13 @@
       </p:sp>
       <p:sp>
         <p:nvSpPr>
-          <p:cNvPr id="24" name="Rounded Rectangle 23"/>
+          <p:cNvPr id="43" name="Rounded Rectangle 42"/>
           <p:cNvSpPr/>
           <p:nvPr/>
         </p:nvSpPr>
         <p:spPr>
           <a:xfrm>
-            <a:off x="3582336" y="2276529"/>
+            <a:off x="3582336" y="2687193"/>
             <a:ext cx="443784" cy="182880"/>
           </a:xfrm>
           <a:prstGeom prst="roundRect">
@@ -7087,13 +8689,13 @@
       </p:sp>
       <p:sp>
         <p:nvSpPr>
-          <p:cNvPr id="25" name="Rounded Rectangle 24"/>
+          <p:cNvPr id="44" name="Rounded Rectangle 43"/>
           <p:cNvSpPr/>
           <p:nvPr/>
         </p:nvSpPr>
         <p:spPr>
           <a:xfrm>
-            <a:off x="3582336" y="2276529"/>
+            <a:off x="3582336" y="2687193"/>
             <a:ext cx="443784" cy="182880"/>
           </a:xfrm>
           <a:prstGeom prst="roundRect">
@@ -7133,14 +8735,14 @@
       </p:sp>
       <p:sp>
         <p:nvSpPr>
-          <p:cNvPr id="26" name="TextBox 25"/>
-          <p:cNvSpPr txBox="1"/>
-          <p:nvPr/>
-        </p:nvSpPr>
-        <p:spPr>
-          <a:xfrm>
-            <a:off x="548640" y="2517212"/>
-            <a:ext cx="2286000" cy="298486"/>
+          <p:cNvPr id="45" name="TextBox 44"/>
+          <p:cNvSpPr txBox="1"/>
+          <p:nvPr/>
+        </p:nvSpPr>
+        <p:spPr>
+          <a:xfrm>
+            <a:off x="548640" y="2936748"/>
+            <a:ext cx="2286000" cy="316230"/>
           </a:xfrm>
           <a:prstGeom prst="rect">
             <a:avLst/>
@@ -7172,14 +8774,14 @@
       </p:sp>
       <p:sp>
         <p:nvSpPr>
-          <p:cNvPr id="27" name="TextBox 26"/>
-          <p:cNvSpPr txBox="1"/>
-          <p:nvPr/>
-        </p:nvSpPr>
-        <p:spPr>
-          <a:xfrm>
-            <a:off x="2148840" y="2517212"/>
-            <a:ext cx="822960" cy="298486"/>
+          <p:cNvPr id="46" name="TextBox 45"/>
+          <p:cNvSpPr txBox="1"/>
+          <p:nvPr/>
+        </p:nvSpPr>
+        <p:spPr>
+          <a:xfrm>
+            <a:off x="2148840" y="2936748"/>
+            <a:ext cx="822960" cy="316230"/>
           </a:xfrm>
           <a:prstGeom prst="rect">
             <a:avLst/>
@@ -7211,13 +8813,13 @@
       </p:sp>
       <p:sp>
         <p:nvSpPr>
-          <p:cNvPr id="28" name="Rounded Rectangle 27"/>
+          <p:cNvPr id="47" name="Rounded Rectangle 46"/>
           <p:cNvSpPr/>
           <p:nvPr/>
         </p:nvSpPr>
         <p:spPr>
           <a:xfrm>
-            <a:off x="4147152" y="2575015"/>
+            <a:off x="4147152" y="3003423"/>
             <a:ext cx="726193" cy="182880"/>
           </a:xfrm>
           <a:prstGeom prst="roundRect">
@@ -7257,13 +8859,13 @@
       </p:sp>
       <p:sp>
         <p:nvSpPr>
-          <p:cNvPr id="29" name="Rounded Rectangle 28"/>
+          <p:cNvPr id="48" name="Rounded Rectangle 47"/>
           <p:cNvSpPr/>
           <p:nvPr/>
         </p:nvSpPr>
         <p:spPr>
           <a:xfrm>
-            <a:off x="4147152" y="2575015"/>
+            <a:off x="4147152" y="3003423"/>
             <a:ext cx="726193" cy="182880"/>
           </a:xfrm>
           <a:prstGeom prst="roundRect">
@@ -7303,14 +8905,14 @@
       </p:sp>
       <p:sp>
         <p:nvSpPr>
-          <p:cNvPr id="30" name="TextBox 29"/>
-          <p:cNvSpPr txBox="1"/>
-          <p:nvPr/>
-        </p:nvSpPr>
-        <p:spPr>
-          <a:xfrm>
-            <a:off x="548640" y="2815698"/>
-            <a:ext cx="2286000" cy="298486"/>
+          <p:cNvPr id="49" name="TextBox 48"/>
+          <p:cNvSpPr txBox="1"/>
+          <p:nvPr/>
+        </p:nvSpPr>
+        <p:spPr>
+          <a:xfrm>
+            <a:off x="548640" y="3252978"/>
+            <a:ext cx="2286000" cy="316230"/>
           </a:xfrm>
           <a:prstGeom prst="rect">
             <a:avLst/>
@@ -7342,14 +8944,14 @@
       </p:sp>
       <p:sp>
         <p:nvSpPr>
-          <p:cNvPr id="31" name="TextBox 30"/>
-          <p:cNvSpPr txBox="1"/>
-          <p:nvPr/>
-        </p:nvSpPr>
-        <p:spPr>
-          <a:xfrm>
-            <a:off x="2148840" y="2815698"/>
-            <a:ext cx="822960" cy="298486"/>
+          <p:cNvPr id="50" name="TextBox 49"/>
+          <p:cNvSpPr txBox="1"/>
+          <p:nvPr/>
+        </p:nvSpPr>
+        <p:spPr>
+          <a:xfrm>
+            <a:off x="2148840" y="3252978"/>
+            <a:ext cx="822960" cy="316230"/>
           </a:xfrm>
           <a:prstGeom prst="rect">
             <a:avLst/>
@@ -7381,13 +8983,13 @@
       </p:sp>
       <p:sp>
         <p:nvSpPr>
-          <p:cNvPr id="32" name="Rounded Rectangle 31"/>
+          <p:cNvPr id="51" name="Rounded Rectangle 50"/>
           <p:cNvSpPr/>
           <p:nvPr/>
         </p:nvSpPr>
         <p:spPr>
           <a:xfrm>
-            <a:off x="4429561" y="2873502"/>
+            <a:off x="4429561" y="3319653"/>
             <a:ext cx="968256" cy="182880"/>
           </a:xfrm>
           <a:prstGeom prst="roundRect">
@@ -7427,13 +9029,13 @@
       </p:sp>
       <p:sp>
         <p:nvSpPr>
-          <p:cNvPr id="33" name="Rounded Rectangle 32"/>
+          <p:cNvPr id="52" name="Rounded Rectangle 51"/>
           <p:cNvSpPr/>
           <p:nvPr/>
         </p:nvSpPr>
         <p:spPr>
           <a:xfrm>
-            <a:off x="4429561" y="2873502"/>
+            <a:off x="4429561" y="3319653"/>
             <a:ext cx="532540" cy="182880"/>
           </a:xfrm>
           <a:prstGeom prst="roundRect">
@@ -7473,14 +9075,14 @@
       </p:sp>
       <p:sp>
         <p:nvSpPr>
-          <p:cNvPr id="34" name="TextBox 33"/>
-          <p:cNvSpPr txBox="1"/>
-          <p:nvPr/>
-        </p:nvSpPr>
-        <p:spPr>
-          <a:xfrm>
-            <a:off x="548640" y="3114185"/>
-            <a:ext cx="2286000" cy="298486"/>
+          <p:cNvPr id="53" name="TextBox 52"/>
+          <p:cNvSpPr txBox="1"/>
+          <p:nvPr/>
+        </p:nvSpPr>
+        <p:spPr>
+          <a:xfrm>
+            <a:off x="548640" y="3569208"/>
+            <a:ext cx="2286000" cy="316230"/>
           </a:xfrm>
           <a:prstGeom prst="rect">
             <a:avLst/>
@@ -7512,14 +9114,14 @@
       </p:sp>
       <p:sp>
         <p:nvSpPr>
-          <p:cNvPr id="35" name="TextBox 34"/>
-          <p:cNvSpPr txBox="1"/>
-          <p:nvPr/>
-        </p:nvSpPr>
-        <p:spPr>
-          <a:xfrm>
-            <a:off x="2148840" y="3114185"/>
-            <a:ext cx="822960" cy="298486"/>
+          <p:cNvPr id="54" name="TextBox 53"/>
+          <p:cNvSpPr txBox="1"/>
+          <p:nvPr/>
+        </p:nvSpPr>
+        <p:spPr>
+          <a:xfrm>
+            <a:off x="2148840" y="3569208"/>
+            <a:ext cx="822960" cy="316230"/>
           </a:xfrm>
           <a:prstGeom prst="rect">
             <a:avLst/>
@@ -7551,13 +9153,13 @@
       </p:sp>
       <p:sp>
         <p:nvSpPr>
-          <p:cNvPr id="36" name="Rounded Rectangle 35"/>
+          <p:cNvPr id="55" name="Rounded Rectangle 54"/>
           <p:cNvSpPr/>
           <p:nvPr/>
         </p:nvSpPr>
         <p:spPr>
           <a:xfrm>
-            <a:off x="4711969" y="3171988"/>
+            <a:off x="4711969" y="3635883"/>
             <a:ext cx="726193" cy="182880"/>
           </a:xfrm>
           <a:prstGeom prst="roundRect">
@@ -7597,13 +9199,13 @@
       </p:sp>
       <p:sp>
         <p:nvSpPr>
-          <p:cNvPr id="37" name="Rounded Rectangle 36"/>
+          <p:cNvPr id="56" name="Rounded Rectangle 55"/>
           <p:cNvSpPr/>
           <p:nvPr/>
         </p:nvSpPr>
         <p:spPr>
           <a:xfrm>
-            <a:off x="4711969" y="3171988"/>
+            <a:off x="4711969" y="3635883"/>
             <a:ext cx="254167" cy="182880"/>
           </a:xfrm>
           <a:prstGeom prst="roundRect">
@@ -7643,14 +9245,14 @@
       </p:sp>
       <p:sp>
         <p:nvSpPr>
-          <p:cNvPr id="38" name="TextBox 37"/>
-          <p:cNvSpPr txBox="1"/>
-          <p:nvPr/>
-        </p:nvSpPr>
-        <p:spPr>
-          <a:xfrm>
-            <a:off x="548640" y="3412671"/>
-            <a:ext cx="2286000" cy="298486"/>
+          <p:cNvPr id="57" name="TextBox 56"/>
+          <p:cNvSpPr txBox="1"/>
+          <p:nvPr/>
+        </p:nvSpPr>
+        <p:spPr>
+          <a:xfrm>
+            <a:off x="548640" y="3885438"/>
+            <a:ext cx="2286000" cy="316230"/>
           </a:xfrm>
           <a:prstGeom prst="rect">
             <a:avLst/>
@@ -7682,14 +9284,14 @@
       </p:sp>
       <p:sp>
         <p:nvSpPr>
-          <p:cNvPr id="39" name="TextBox 38"/>
-          <p:cNvSpPr txBox="1"/>
-          <p:nvPr/>
-        </p:nvSpPr>
-        <p:spPr>
-          <a:xfrm>
-            <a:off x="2148840" y="3412671"/>
-            <a:ext cx="822960" cy="298486"/>
+          <p:cNvPr id="58" name="TextBox 57"/>
+          <p:cNvSpPr txBox="1"/>
+          <p:nvPr/>
+        </p:nvSpPr>
+        <p:spPr>
+          <a:xfrm>
+            <a:off x="2148840" y="3885438"/>
+            <a:ext cx="822960" cy="316230"/>
           </a:xfrm>
           <a:prstGeom prst="rect">
             <a:avLst/>
@@ -7721,13 +9323,13 @@
       </p:sp>
       <p:sp>
         <p:nvSpPr>
-          <p:cNvPr id="40" name="Rounded Rectangle 39"/>
+          <p:cNvPr id="59" name="Rounded Rectangle 58"/>
           <p:cNvSpPr/>
           <p:nvPr/>
         </p:nvSpPr>
         <p:spPr>
           <a:xfrm>
-            <a:off x="5559194" y="3470474"/>
+            <a:off x="5559194" y="3952113"/>
             <a:ext cx="161376" cy="182880"/>
           </a:xfrm>
           <a:prstGeom prst="roundRect">
@@ -7767,14 +9369,14 @@
       </p:sp>
       <p:sp>
         <p:nvSpPr>
-          <p:cNvPr id="41" name="TextBox 40"/>
-          <p:cNvSpPr txBox="1"/>
-          <p:nvPr/>
-        </p:nvSpPr>
-        <p:spPr>
-          <a:xfrm>
-            <a:off x="548640" y="3711157"/>
-            <a:ext cx="2286000" cy="298486"/>
+          <p:cNvPr id="60" name="TextBox 59"/>
+          <p:cNvSpPr txBox="1"/>
+          <p:nvPr/>
+        </p:nvSpPr>
+        <p:spPr>
+          <a:xfrm>
+            <a:off x="548640" y="4201668"/>
+            <a:ext cx="2286000" cy="316230"/>
           </a:xfrm>
           <a:prstGeom prst="rect">
             <a:avLst/>
@@ -7806,14 +9408,14 @@
       </p:sp>
       <p:sp>
         <p:nvSpPr>
-          <p:cNvPr id="42" name="TextBox 41"/>
-          <p:cNvSpPr txBox="1"/>
-          <p:nvPr/>
-        </p:nvSpPr>
-        <p:spPr>
-          <a:xfrm>
-            <a:off x="2148840" y="3711157"/>
-            <a:ext cx="822960" cy="298486"/>
+          <p:cNvPr id="61" name="TextBox 60"/>
+          <p:cNvSpPr txBox="1"/>
+          <p:nvPr/>
+        </p:nvSpPr>
+        <p:spPr>
+          <a:xfrm>
+            <a:off x="2148840" y="4201668"/>
+            <a:ext cx="822960" cy="316230"/>
           </a:xfrm>
           <a:prstGeom prst="rect">
             <a:avLst/>
@@ -7845,13 +9447,13 @@
       </p:sp>
       <p:sp>
         <p:nvSpPr>
-          <p:cNvPr id="43" name="Rounded Rectangle 42"/>
+          <p:cNvPr id="62" name="Rounded Rectangle 61"/>
           <p:cNvSpPr/>
           <p:nvPr/>
         </p:nvSpPr>
         <p:spPr>
           <a:xfrm>
-            <a:off x="5841602" y="3768960"/>
+            <a:off x="5841602" y="4268343"/>
             <a:ext cx="726192" cy="182880"/>
           </a:xfrm>
           <a:prstGeom prst="roundRect">
@@ -7891,14 +9493,14 @@
       </p:sp>
       <p:sp>
         <p:nvSpPr>
-          <p:cNvPr id="44" name="TextBox 43"/>
-          <p:cNvSpPr txBox="1"/>
-          <p:nvPr/>
-        </p:nvSpPr>
-        <p:spPr>
-          <a:xfrm>
-            <a:off x="548640" y="4009644"/>
-            <a:ext cx="2286000" cy="298486"/>
+          <p:cNvPr id="63" name="TextBox 62"/>
+          <p:cNvSpPr txBox="1"/>
+          <p:nvPr/>
+        </p:nvSpPr>
+        <p:spPr>
+          <a:xfrm>
+            <a:off x="548640" y="4517898"/>
+            <a:ext cx="2286000" cy="316230"/>
           </a:xfrm>
           <a:prstGeom prst="rect">
             <a:avLst/>
@@ -7930,14 +9532,14 @@
       </p:sp>
       <p:sp>
         <p:nvSpPr>
-          <p:cNvPr id="45" name="TextBox 44"/>
-          <p:cNvSpPr txBox="1"/>
-          <p:nvPr/>
-        </p:nvSpPr>
-        <p:spPr>
-          <a:xfrm>
-            <a:off x="2148840" y="4009644"/>
-            <a:ext cx="822960" cy="298486"/>
+          <p:cNvPr id="64" name="TextBox 63"/>
+          <p:cNvSpPr txBox="1"/>
+          <p:nvPr/>
+        </p:nvSpPr>
+        <p:spPr>
+          <a:xfrm>
+            <a:off x="2148840" y="4517898"/>
+            <a:ext cx="822960" cy="316230"/>
           </a:xfrm>
           <a:prstGeom prst="rect">
             <a:avLst/>
@@ -7969,13 +9571,13 @@
       </p:sp>
       <p:sp>
         <p:nvSpPr>
-          <p:cNvPr id="46" name="Rounded Rectangle 45"/>
+          <p:cNvPr id="65" name="Rounded Rectangle 64"/>
           <p:cNvSpPr/>
           <p:nvPr/>
         </p:nvSpPr>
         <p:spPr>
           <a:xfrm>
-            <a:off x="6688827" y="4067447"/>
+            <a:off x="6688827" y="4584573"/>
             <a:ext cx="726192" cy="182880"/>
           </a:xfrm>
           <a:prstGeom prst="roundRect">
@@ -8015,14 +9617,14 @@
       </p:sp>
       <p:sp>
         <p:nvSpPr>
-          <p:cNvPr id="47" name="TextBox 46"/>
-          <p:cNvSpPr txBox="1"/>
-          <p:nvPr/>
-        </p:nvSpPr>
-        <p:spPr>
-          <a:xfrm>
-            <a:off x="548640" y="4308130"/>
-            <a:ext cx="2286000" cy="298486"/>
+          <p:cNvPr id="66" name="TextBox 65"/>
+          <p:cNvSpPr txBox="1"/>
+          <p:nvPr/>
+        </p:nvSpPr>
+        <p:spPr>
+          <a:xfrm>
+            <a:off x="548640" y="4834128"/>
+            <a:ext cx="2286000" cy="316230"/>
           </a:xfrm>
           <a:prstGeom prst="rect">
             <a:avLst/>
@@ -8054,14 +9656,14 @@
       </p:sp>
       <p:sp>
         <p:nvSpPr>
-          <p:cNvPr id="48" name="TextBox 47"/>
-          <p:cNvSpPr txBox="1"/>
-          <p:nvPr/>
-        </p:nvSpPr>
-        <p:spPr>
-          <a:xfrm>
-            <a:off x="2148840" y="4308130"/>
-            <a:ext cx="822960" cy="298486"/>
+          <p:cNvPr id="67" name="TextBox 66"/>
+          <p:cNvSpPr txBox="1"/>
+          <p:nvPr/>
+        </p:nvSpPr>
+        <p:spPr>
+          <a:xfrm>
+            <a:off x="2148840" y="4834128"/>
+            <a:ext cx="822960" cy="316230"/>
           </a:xfrm>
           <a:prstGeom prst="rect">
             <a:avLst/>
@@ -8093,13 +9695,13 @@
       </p:sp>
       <p:sp>
         <p:nvSpPr>
-          <p:cNvPr id="49" name="Rounded Rectangle 48"/>
+          <p:cNvPr id="68" name="Rounded Rectangle 67"/>
           <p:cNvSpPr/>
           <p:nvPr/>
         </p:nvSpPr>
         <p:spPr>
           <a:xfrm>
-            <a:off x="7536051" y="4365933"/>
+            <a:off x="7536051" y="4900803"/>
             <a:ext cx="1291009" cy="182880"/>
           </a:xfrm>
           <a:prstGeom prst="roundRect">
@@ -8139,14 +9741,14 @@
       </p:sp>
       <p:sp>
         <p:nvSpPr>
-          <p:cNvPr id="50" name="TextBox 49"/>
-          <p:cNvSpPr txBox="1"/>
-          <p:nvPr/>
-        </p:nvSpPr>
-        <p:spPr>
-          <a:xfrm>
-            <a:off x="548640" y="4606616"/>
-            <a:ext cx="2286000" cy="298486"/>
+          <p:cNvPr id="69" name="TextBox 68"/>
+          <p:cNvSpPr txBox="1"/>
+          <p:nvPr/>
+        </p:nvSpPr>
+        <p:spPr>
+          <a:xfrm>
+            <a:off x="548640" y="5150358"/>
+            <a:ext cx="2286000" cy="316230"/>
           </a:xfrm>
           <a:prstGeom prst="rect">
             <a:avLst/>
@@ -8178,14 +9780,14 @@
       </p:sp>
       <p:sp>
         <p:nvSpPr>
-          <p:cNvPr id="51" name="TextBox 50"/>
-          <p:cNvSpPr txBox="1"/>
-          <p:nvPr/>
-        </p:nvSpPr>
-        <p:spPr>
-          <a:xfrm>
-            <a:off x="2148840" y="4606616"/>
-            <a:ext cx="822960" cy="298486"/>
+          <p:cNvPr id="70" name="TextBox 69"/>
+          <p:cNvSpPr txBox="1"/>
+          <p:nvPr/>
+        </p:nvSpPr>
+        <p:spPr>
+          <a:xfrm>
+            <a:off x="2148840" y="5150358"/>
+            <a:ext cx="822960" cy="316230"/>
           </a:xfrm>
           <a:prstGeom prst="rect">
             <a:avLst/>
@@ -8217,13 +9819,13 @@
       </p:sp>
       <p:sp>
         <p:nvSpPr>
-          <p:cNvPr id="52" name="Rounded Rectangle 51"/>
+          <p:cNvPr id="71" name="Rounded Rectangle 70"/>
           <p:cNvSpPr/>
           <p:nvPr/>
         </p:nvSpPr>
         <p:spPr>
           <a:xfrm>
-            <a:off x="8383276" y="4664419"/>
+            <a:off x="8383276" y="5217033"/>
             <a:ext cx="1008601" cy="182880"/>
           </a:xfrm>
           <a:prstGeom prst="roundRect">
@@ -8263,14 +9865,14 @@
       </p:sp>
       <p:sp>
         <p:nvSpPr>
-          <p:cNvPr id="53" name="TextBox 52"/>
-          <p:cNvSpPr txBox="1"/>
-          <p:nvPr/>
-        </p:nvSpPr>
-        <p:spPr>
-          <a:xfrm>
-            <a:off x="548640" y="4905102"/>
-            <a:ext cx="2286000" cy="298486"/>
+          <p:cNvPr id="72" name="TextBox 71"/>
+          <p:cNvSpPr txBox="1"/>
+          <p:nvPr/>
+        </p:nvSpPr>
+        <p:spPr>
+          <a:xfrm>
+            <a:off x="548640" y="5466588"/>
+            <a:ext cx="2286000" cy="316230"/>
           </a:xfrm>
           <a:prstGeom prst="rect">
             <a:avLst/>
@@ -8302,14 +9904,14 @@
       </p:sp>
       <p:sp>
         <p:nvSpPr>
-          <p:cNvPr id="54" name="TextBox 53"/>
-          <p:cNvSpPr txBox="1"/>
-          <p:nvPr/>
-        </p:nvSpPr>
-        <p:spPr>
-          <a:xfrm>
-            <a:off x="2148840" y="4905102"/>
-            <a:ext cx="822960" cy="298486"/>
+          <p:cNvPr id="73" name="TextBox 72"/>
+          <p:cNvSpPr txBox="1"/>
+          <p:nvPr/>
+        </p:nvSpPr>
+        <p:spPr>
+          <a:xfrm>
+            <a:off x="2148840" y="5466588"/>
+            <a:ext cx="822960" cy="316230"/>
           </a:xfrm>
           <a:prstGeom prst="rect">
             <a:avLst/>
@@ -8341,13 +9943,13 @@
       </p:sp>
       <p:sp>
         <p:nvSpPr>
-          <p:cNvPr id="55" name="Rounded Rectangle 54"/>
+          <p:cNvPr id="74" name="Rounded Rectangle 73"/>
           <p:cNvSpPr/>
           <p:nvPr/>
         </p:nvSpPr>
         <p:spPr>
           <a:xfrm>
-            <a:off x="9230501" y="4962906"/>
+            <a:off x="9230501" y="5533263"/>
             <a:ext cx="726192" cy="182880"/>
           </a:xfrm>
           <a:prstGeom prst="roundRect">
@@ -8387,14 +9989,14 @@
       </p:sp>
       <p:sp>
         <p:nvSpPr>
-          <p:cNvPr id="56" name="TextBox 55"/>
-          <p:cNvSpPr txBox="1"/>
-          <p:nvPr/>
-        </p:nvSpPr>
-        <p:spPr>
-          <a:xfrm>
-            <a:off x="548640" y="5203589"/>
-            <a:ext cx="2286000" cy="298486"/>
+          <p:cNvPr id="75" name="TextBox 74"/>
+          <p:cNvSpPr txBox="1"/>
+          <p:nvPr/>
+        </p:nvSpPr>
+        <p:spPr>
+          <a:xfrm>
+            <a:off x="548640" y="5782818"/>
+            <a:ext cx="2286000" cy="316230"/>
           </a:xfrm>
           <a:prstGeom prst="rect">
             <a:avLst/>
@@ -8426,14 +10028,14 @@
       </p:sp>
       <p:sp>
         <p:nvSpPr>
-          <p:cNvPr id="57" name="TextBox 56"/>
-          <p:cNvSpPr txBox="1"/>
-          <p:nvPr/>
-        </p:nvSpPr>
-        <p:spPr>
-          <a:xfrm>
-            <a:off x="2148840" y="5203589"/>
-            <a:ext cx="822960" cy="298486"/>
+          <p:cNvPr id="76" name="TextBox 75"/>
+          <p:cNvSpPr txBox="1"/>
+          <p:nvPr/>
+        </p:nvSpPr>
+        <p:spPr>
+          <a:xfrm>
+            <a:off x="2148840" y="5782818"/>
+            <a:ext cx="822960" cy="316230"/>
           </a:xfrm>
           <a:prstGeom prst="rect">
             <a:avLst/>
@@ -8465,13 +10067,13 @@
       </p:sp>
       <p:sp>
         <p:nvSpPr>
-          <p:cNvPr id="58" name="Rounded Rectangle 57"/>
+          <p:cNvPr id="77" name="Rounded Rectangle 76"/>
           <p:cNvSpPr/>
           <p:nvPr/>
         </p:nvSpPr>
         <p:spPr>
           <a:xfrm>
-            <a:off x="9795317" y="5261392"/>
+            <a:off x="9795317" y="5849493"/>
             <a:ext cx="443785" cy="182880"/>
           </a:xfrm>
           <a:prstGeom prst="roundRect">
@@ -8509,257 +10111,9 @@
           </a:p>
         </p:txBody>
       </p:sp>
-      <p:sp>
-        <p:nvSpPr>
-          <p:cNvPr id="59" name="TextBox 58"/>
-          <p:cNvSpPr txBox="1"/>
-          <p:nvPr/>
-        </p:nvSpPr>
-        <p:spPr>
-          <a:xfrm>
-            <a:off x="548640" y="5502075"/>
-            <a:ext cx="2286000" cy="298486"/>
-          </a:xfrm>
-          <a:prstGeom prst="rect">
-            <a:avLst/>
-          </a:prstGeom>
-          <a:noFill/>
-        </p:spPr>
-        <p:txBody>
-          <a:bodyPr wrap="square" lIns="0" rIns="0" tIns="0" bIns="0" anchor="ctr">
-            <a:spAutoFit/>
-          </a:bodyPr>
-          <a:lstStyle/>
-          <a:p>
-            <a:pPr algn="l">
-              <a:lnSpc>
-                <a:spcPct val="115000"/>
-              </a:lnSpc>
-            </a:pPr>
-            <a:r>
-              <a:rPr sz="950" b="0" i="0">
-                <a:solidFill>
-                  <a:srgbClr val="1A1A1A"/>
-                </a:solidFill>
-                <a:latin typeface="Calibri"/>
-              </a:rPr>
-              <a:t>Commissioning</a:t>
-            </a:r>
-          </a:p>
-        </p:txBody>
-      </p:sp>
-      <p:sp>
-        <p:nvSpPr>
-          <p:cNvPr id="60" name="TextBox 59"/>
-          <p:cNvSpPr txBox="1"/>
-          <p:nvPr/>
-        </p:nvSpPr>
-        <p:spPr>
-          <a:xfrm>
-            <a:off x="2148840" y="5502075"/>
-            <a:ext cx="822960" cy="298486"/>
-          </a:xfrm>
-          <a:prstGeom prst="rect">
-            <a:avLst/>
-          </a:prstGeom>
-          <a:noFill/>
-        </p:spPr>
-        <p:txBody>
-          <a:bodyPr wrap="square" lIns="0" rIns="0" tIns="0" bIns="0" anchor="ctr">
-            <a:spAutoFit/>
-          </a:bodyPr>
-          <a:lstStyle/>
-          <a:p>
-            <a:pPr algn="r">
-              <a:lnSpc>
-                <a:spcPct val="115000"/>
-              </a:lnSpc>
-            </a:pPr>
-            <a:r>
-              <a:rPr sz="800" b="0" i="1">
-                <a:solidFill>
-                  <a:srgbClr val="8A8A8A"/>
-                </a:solidFill>
-                <a:latin typeface="Calibri"/>
-              </a:rPr>
-              <a:t>Contractor</a:t>
-            </a:r>
-          </a:p>
-        </p:txBody>
-      </p:sp>
-      <p:sp>
-        <p:nvSpPr>
-          <p:cNvPr id="61" name="Rounded Rectangle 60"/>
-          <p:cNvSpPr/>
-          <p:nvPr/>
-        </p:nvSpPr>
-        <p:spPr>
-          <a:xfrm>
-            <a:off x="10360134" y="5559878"/>
-            <a:ext cx="443784" cy="182880"/>
-          </a:xfrm>
-          <a:prstGeom prst="roundRect">
-            <a:avLst>
-              <a:gd name="adj" fmla="val 45000"/>
-            </a:avLst>
-          </a:prstGeom>
-          <a:solidFill>
-            <a:srgbClr val="E7E9EC"/>
-          </a:solidFill>
-          <a:ln>
-            <a:noFill/>
-          </a:ln>
-          <a:effectLst/>
-        </p:spPr>
-        <p:style>
-          <a:lnRef idx="1">
-            <a:schemeClr val="accent1"/>
-          </a:lnRef>
-          <a:fillRef idx="3">
-            <a:schemeClr val="accent1"/>
-          </a:fillRef>
-          <a:effectRef idx="2">
-            <a:schemeClr val="accent1"/>
-          </a:effectRef>
-          <a:fontRef idx="minor">
-            <a:schemeClr val="lt1"/>
-          </a:fontRef>
-        </p:style>
-        <p:txBody>
-          <a:bodyPr rtlCol="0" anchor="ctr"/>
-          <a:lstStyle/>
-          <a:p>
-            <a:pPr algn="ctr"/>
-          </a:p>
-        </p:txBody>
-      </p:sp>
-      <p:sp>
-        <p:nvSpPr>
-          <p:cNvPr id="62" name="TextBox 61"/>
-          <p:cNvSpPr txBox="1"/>
-          <p:nvPr/>
-        </p:nvSpPr>
-        <p:spPr>
-          <a:xfrm>
-            <a:off x="548640" y="5800561"/>
-            <a:ext cx="2286000" cy="298486"/>
-          </a:xfrm>
-          <a:prstGeom prst="rect">
-            <a:avLst/>
-          </a:prstGeom>
-          <a:noFill/>
-        </p:spPr>
-        <p:txBody>
-          <a:bodyPr wrap="square" lIns="0" rIns="0" tIns="0" bIns="0" anchor="ctr">
-            <a:spAutoFit/>
-          </a:bodyPr>
-          <a:lstStyle/>
-          <a:p>
-            <a:pPr algn="l">
-              <a:lnSpc>
-                <a:spcPct val="115000"/>
-              </a:lnSpc>
-            </a:pPr>
-            <a:r>
-              <a:rPr sz="950" b="0" i="0">
-                <a:solidFill>
-                  <a:srgbClr val="1A1A1A"/>
-                </a:solidFill>
-                <a:latin typeface="Calibri"/>
-              </a:rPr>
-              <a:t>Snagging &amp; client sign-off</a:t>
-            </a:r>
-          </a:p>
-        </p:txBody>
-      </p:sp>
-      <p:sp>
-        <p:nvSpPr>
-          <p:cNvPr id="63" name="TextBox 62"/>
-          <p:cNvSpPr txBox="1"/>
-          <p:nvPr/>
-        </p:nvSpPr>
-        <p:spPr>
-          <a:xfrm>
-            <a:off x="2148840" y="5800561"/>
-            <a:ext cx="822960" cy="298486"/>
-          </a:xfrm>
-          <a:prstGeom prst="rect">
-            <a:avLst/>
-          </a:prstGeom>
-          <a:noFill/>
-        </p:spPr>
-        <p:txBody>
-          <a:bodyPr wrap="square" lIns="0" rIns="0" tIns="0" bIns="0" anchor="ctr">
-            <a:spAutoFit/>
-          </a:bodyPr>
-          <a:lstStyle/>
-          <a:p>
-            <a:pPr algn="r">
-              <a:lnSpc>
-                <a:spcPct val="115000"/>
-              </a:lnSpc>
-            </a:pPr>
-            <a:r>
-              <a:rPr sz="800" b="0" i="1">
-                <a:solidFill>
-                  <a:srgbClr val="8A8A8A"/>
-                </a:solidFill>
-                <a:latin typeface="Calibri"/>
-              </a:rPr>
-              <a:t>PM</a:t>
-            </a:r>
-          </a:p>
-        </p:txBody>
-      </p:sp>
-      <p:sp>
-        <p:nvSpPr>
-          <p:cNvPr id="64" name="Rounded Rectangle 63"/>
-          <p:cNvSpPr/>
-          <p:nvPr/>
-        </p:nvSpPr>
-        <p:spPr>
-          <a:xfrm>
-            <a:off x="10924950" y="5858364"/>
-            <a:ext cx="443785" cy="182880"/>
-          </a:xfrm>
-          <a:prstGeom prst="roundRect">
-            <a:avLst>
-              <a:gd name="adj" fmla="val 45000"/>
-            </a:avLst>
-          </a:prstGeom>
-          <a:solidFill>
-            <a:srgbClr val="E7E9EC"/>
-          </a:solidFill>
-          <a:ln>
-            <a:noFill/>
-          </a:ln>
-          <a:effectLst/>
-        </p:spPr>
-        <p:style>
-          <a:lnRef idx="1">
-            <a:schemeClr val="accent1"/>
-          </a:lnRef>
-          <a:fillRef idx="3">
-            <a:schemeClr val="accent1"/>
-          </a:fillRef>
-          <a:effectRef idx="2">
-            <a:schemeClr val="accent1"/>
-          </a:effectRef>
-          <a:fontRef idx="minor">
-            <a:schemeClr val="lt1"/>
-          </a:fontRef>
-        </p:style>
-        <p:txBody>
-          <a:bodyPr rtlCol="0" anchor="ctr"/>
-          <a:lstStyle/>
-          <a:p>
-            <a:pPr algn="ctr"/>
-          </a:p>
-        </p:txBody>
-      </p:sp>
       <p:cxnSp>
         <p:nvCxnSpPr>
-          <p:cNvPr id="65" name="Connector 64"/>
+          <p:cNvPr id="78" name="Connector 77"/>
           <p:cNvCxnSpPr/>
           <p:nvPr/>
         </p:nvCxnSpPr>
@@ -8796,7 +10150,7 @@
       </p:cxnSp>
       <p:sp>
         <p:nvSpPr>
-          <p:cNvPr id="66" name="TextBox 65"/>
+          <p:cNvPr id="79" name="TextBox 78"/>
           <p:cNvSpPr txBox="1"/>
           <p:nvPr/>
         </p:nvSpPr>
@@ -8835,7 +10189,7 @@
       </p:sp>
       <p:sp>
         <p:nvSpPr>
-          <p:cNvPr id="67" name="TextBox 66"/>
+          <p:cNvPr id="80" name="TextBox 79"/>
           <p:cNvSpPr txBox="1"/>
           <p:nvPr/>
         </p:nvSpPr>
@@ -8874,7 +10228,7 @@
       </p:sp>
       <p:cxnSp>
         <p:nvCxnSpPr>
-          <p:cNvPr id="68" name="Connector 67"/>
+          <p:cNvPr id="81" name="Connector 80"/>
           <p:cNvCxnSpPr/>
           <p:nvPr/>
         </p:nvCxnSpPr>
@@ -8910,7 +10264,7 @@
       </p:cxnSp>
       <p:pic>
         <p:nvPicPr>
-          <p:cNvPr id="69" name="Picture 68" descr="acme-logo.png"/>
+          <p:cNvPr id="82" name="Picture 81" descr="acme-logo.png"/>
           <p:cNvPicPr>
             <a:picLocks noChangeAspect="1"/>
           </p:cNvPicPr>
@@ -8934,7 +10288,7 @@
       </p:pic>
       <p:sp>
         <p:nvSpPr>
-          <p:cNvPr id="70" name="TextBox 69"/>
+          <p:cNvPr id="83" name="TextBox 82"/>
           <p:cNvSpPr txBox="1"/>
           <p:nvPr/>
         </p:nvSpPr>
@@ -8973,7 +10327,7 @@
       </p:sp>
       <p:sp>
         <p:nvSpPr>
-          <p:cNvPr id="71" name="TextBox 70"/>
+          <p:cNvPr id="84" name="TextBox 83"/>
           <p:cNvSpPr txBox="1"/>
           <p:nvPr/>
         </p:nvSpPr>

</xml_diff>